<commit_message>
feat: add dark mode with system preference detection and toggle
</commit_message>
<xml_diff>
--- a/PitStop_ElevatorPitch.pptx
+++ b/PitStop_ElevatorPitch.pptx
@@ -3088,7 +3088,7 @@
     <p:bg>
       <p:bgPr>
         <a:solidFill>
-          <a:srgbClr val="12122A"/>
+          <a:srgbClr val="013E68"/>
         </a:solidFill>
         <a:effectLst/>
       </p:bgPr>
@@ -3100,52 +3100,9 @@
         <p:nvPr/>
       </p:nvGrpSpPr>
       <p:grpSpPr/>
-      <p:sp>
-        <p:nvSpPr>
-          <p:cNvPr id="2" name="Rectangle 1"/>
-          <p:cNvSpPr/>
-          <p:nvPr/>
-        </p:nvSpPr>
-        <p:spPr>
-          <a:xfrm>
-            <a:off x="0" y="0"/>
-            <a:ext cx="164592" cy="6858000"/>
-          </a:xfrm>
-          <a:prstGeom prst="rect">
-            <a:avLst/>
-          </a:prstGeom>
-          <a:solidFill>
-            <a:srgbClr val="F5A623"/>
-          </a:solidFill>
-          <a:ln>
-            <a:noFill/>
-          </a:ln>
-        </p:spPr>
-        <p:style>
-          <a:lnRef idx="1">
-            <a:schemeClr val="accent1"/>
-          </a:lnRef>
-          <a:fillRef idx="3">
-            <a:schemeClr val="accent1"/>
-          </a:fillRef>
-          <a:effectRef idx="2">
-            <a:schemeClr val="accent1"/>
-          </a:effectRef>
-          <a:fontRef idx="minor">
-            <a:schemeClr val="lt1"/>
-          </a:fontRef>
-        </p:style>
-        <p:txBody>
-          <a:bodyPr rtlCol="0" anchor="ctr"/>
-          <a:lstStyle/>
-          <a:p>
-            <a:pPr algn="ctr"/>
-          </a:p>
-        </p:txBody>
-      </p:sp>
       <p:pic>
         <p:nvPicPr>
-          <p:cNvPr id="3" name="Picture 2" descr="logoPitStop.png"/>
+          <p:cNvPr id="2" name="Picture 1" descr="pitstop_grad.png"/>
           <p:cNvPicPr>
             <a:picLocks noChangeAspect="1"/>
           </p:cNvPicPr>
@@ -3159,8 +3116,8 @@
         </p:blipFill>
         <p:spPr>
           <a:xfrm>
-            <a:off x="8961120" y="731520"/>
-            <a:ext cx="2560320" cy="2560320"/>
+            <a:off x="5138928" y="0"/>
+            <a:ext cx="7050024" cy="6858000"/>
           </a:xfrm>
           <a:prstGeom prst="rect">
             <a:avLst/>
@@ -3169,14 +3126,124 @@
       </p:pic>
       <p:sp>
         <p:nvSpPr>
-          <p:cNvPr id="4" name="TextBox 3"/>
+          <p:cNvPr id="3" name="Rectangle 2"/>
+          <p:cNvSpPr/>
+          <p:nvPr/>
+        </p:nvSpPr>
+        <p:spPr>
+          <a:xfrm>
+            <a:off x="0" y="0"/>
+            <a:ext cx="5120640" cy="6858000"/>
+          </a:xfrm>
+          <a:prstGeom prst="rect">
+            <a:avLst/>
+          </a:prstGeom>
+          <a:solidFill>
+            <a:srgbClr val="016CB0"/>
+          </a:solidFill>
+          <a:ln>
+            <a:noFill/>
+          </a:ln>
+        </p:spPr>
+        <p:style>
+          <a:lnRef idx="1">
+            <a:schemeClr val="accent1"/>
+          </a:lnRef>
+          <a:fillRef idx="3">
+            <a:schemeClr val="accent1"/>
+          </a:fillRef>
+          <a:effectRef idx="2">
+            <a:schemeClr val="accent1"/>
+          </a:effectRef>
+          <a:fontRef idx="minor">
+            <a:schemeClr val="lt1"/>
+          </a:fontRef>
+        </p:style>
+        <p:txBody>
+          <a:bodyPr rtlCol="0" anchor="ctr"/>
+          <a:lstStyle/>
+          <a:p>
+            <a:pPr algn="ctr"/>
+          </a:p>
+        </p:txBody>
+      </p:sp>
+      <p:pic>
+        <p:nvPicPr>
+          <p:cNvPr id="4" name="Picture 3" descr="logoPitStop.png"/>
+          <p:cNvPicPr>
+            <a:picLocks noChangeAspect="1"/>
+          </p:cNvPicPr>
+          <p:nvPr/>
+        </p:nvPicPr>
+        <p:blipFill>
+          <a:blip r:embed="rId3"/>
+          <a:stretch>
+            <a:fillRect/>
+          </a:stretch>
+        </p:blipFill>
+        <p:spPr>
+          <a:xfrm>
+            <a:off x="502920" y="1463040"/>
+            <a:ext cx="4114800" cy="4114800"/>
+          </a:xfrm>
+          <a:prstGeom prst="rect">
+            <a:avLst/>
+          </a:prstGeom>
+        </p:spPr>
+      </p:pic>
+      <p:sp>
+        <p:nvSpPr>
+          <p:cNvPr id="5" name="Rectangle 4"/>
+          <p:cNvSpPr/>
+          <p:nvPr/>
+        </p:nvSpPr>
+        <p:spPr>
+          <a:xfrm>
+            <a:off x="5102352" y="0"/>
+            <a:ext cx="36576" cy="6858000"/>
+          </a:xfrm>
+          <a:prstGeom prst="rect">
+            <a:avLst/>
+          </a:prstGeom>
+          <a:solidFill>
+            <a:srgbClr val="FFFFFF"/>
+          </a:solidFill>
+          <a:ln>
+            <a:noFill/>
+          </a:ln>
+        </p:spPr>
+        <p:style>
+          <a:lnRef idx="1">
+            <a:schemeClr val="accent1"/>
+          </a:lnRef>
+          <a:fillRef idx="3">
+            <a:schemeClr val="accent1"/>
+          </a:fillRef>
+          <a:effectRef idx="2">
+            <a:schemeClr val="accent1"/>
+          </a:effectRef>
+          <a:fontRef idx="minor">
+            <a:schemeClr val="lt1"/>
+          </a:fontRef>
+        </p:style>
+        <p:txBody>
+          <a:bodyPr rtlCol="0" anchor="ctr"/>
+          <a:lstStyle/>
+          <a:p>
+            <a:pPr algn="ctr"/>
+          </a:p>
+        </p:txBody>
+      </p:sp>
+      <p:sp>
+        <p:nvSpPr>
+          <p:cNvPr id="6" name="TextBox 5"/>
           <p:cNvSpPr txBox="1"/>
           <p:nvPr/>
         </p:nvSpPr>
         <p:spPr>
           <a:xfrm>
-            <a:off x="457200" y="914400"/>
-            <a:ext cx="6858000" cy="457200"/>
+            <a:off x="5486400" y="1005840"/>
+            <a:ext cx="6400800" cy="411480"/>
           </a:xfrm>
           <a:prstGeom prst="rect">
             <a:avLst/>
@@ -3191,9 +3258,9 @@
           <a:p>
             <a:pPr algn="l"/>
             <a:r>
-              <a:rPr sz="1200" b="1" i="0">
+              <a:rPr sz="1100" b="1" i="0">
                 <a:solidFill>
-                  <a:srgbClr val="F5A623"/>
+                  <a:srgbClr val="0589D6"/>
                 </a:solidFill>
                 <a:latin typeface="Calibri"/>
               </a:rPr>
@@ -3204,14 +3271,14 @@
       </p:sp>
       <p:sp>
         <p:nvSpPr>
-          <p:cNvPr id="5" name="TextBox 4"/>
+          <p:cNvPr id="7" name="TextBox 6"/>
           <p:cNvSpPr txBox="1"/>
           <p:nvPr/>
         </p:nvSpPr>
         <p:spPr>
           <a:xfrm>
-            <a:off x="457200" y="1554480"/>
-            <a:ext cx="7315200" cy="1371600"/>
+            <a:off x="5486400" y="1828800"/>
+            <a:ext cx="6400800" cy="1645920"/>
           </a:xfrm>
           <a:prstGeom prst="rect">
             <a:avLst/>
@@ -3226,47 +3293,12 @@
           <a:p>
             <a:pPr algn="l"/>
             <a:r>
-              <a:rPr sz="7200" b="1" i="0">
+              <a:rPr sz="3600" b="1" i="0">
                 <a:solidFill>
                   <a:srgbClr val="FFFFFF"/>
                 </a:solidFill>
                 <a:latin typeface="Calibri"/>
               </a:rPr>
-              <a:t>PitStop</a:t>
-            </a:r>
-          </a:p>
-        </p:txBody>
-      </p:sp>
-      <p:sp>
-        <p:nvSpPr>
-          <p:cNvPr id="6" name="TextBox 5"/>
-          <p:cNvSpPr txBox="1"/>
-          <p:nvPr/>
-        </p:nvSpPr>
-        <p:spPr>
-          <a:xfrm>
-            <a:off x="457200" y="3017520"/>
-            <a:ext cx="7315200" cy="1280160"/>
-          </a:xfrm>
-          <a:prstGeom prst="rect">
-            <a:avLst/>
-          </a:prstGeom>
-          <a:noFill/>
-        </p:spPr>
-        <p:txBody>
-          <a:bodyPr wrap="square">
-            <a:spAutoFit/>
-          </a:bodyPr>
-          <a:lstStyle/>
-          <a:p>
-            <a:pPr algn="l"/>
-            <a:r>
-              <a:rPr sz="2800" b="0" i="0">
-                <a:solidFill>
-                  <a:srgbClr val="C5C5D8"/>
-                </a:solidFill>
-                <a:latin typeface="Calibri"/>
-              </a:rPr>
               <a:t>El control de tu coche,
 en tu bolsillo.</a:t>
             </a:r>
@@ -3275,20 +3307,20 @@
       </p:sp>
       <p:sp>
         <p:nvSpPr>
-          <p:cNvPr id="7" name="Rectangle 6"/>
+          <p:cNvPr id="8" name="Rectangle 7"/>
           <p:cNvSpPr/>
           <p:nvPr/>
         </p:nvSpPr>
         <p:spPr>
           <a:xfrm>
-            <a:off x="0" y="6217920"/>
-            <a:ext cx="12188952" cy="640080"/>
+            <a:off x="5138928" y="6035040"/>
+            <a:ext cx="7050024" cy="822960"/>
           </a:xfrm>
           <a:prstGeom prst="rect">
             <a:avLst/>
           </a:prstGeom>
           <a:solidFill>
-            <a:srgbClr val="0D0D22"/>
+            <a:srgbClr val="011F3A"/>
           </a:solidFill>
           <a:ln>
             <a:noFill/>
@@ -3318,14 +3350,14 @@
       </p:sp>
       <p:sp>
         <p:nvSpPr>
-          <p:cNvPr id="8" name="TextBox 7"/>
+          <p:cNvPr id="9" name="TextBox 8"/>
           <p:cNvSpPr txBox="1"/>
           <p:nvPr/>
         </p:nvSpPr>
         <p:spPr>
           <a:xfrm>
-            <a:off x="457200" y="6281928"/>
-            <a:ext cx="10972800" cy="457200"/>
+            <a:off x="5303520" y="6099048"/>
+            <a:ext cx="6766560" cy="457200"/>
           </a:xfrm>
           <a:prstGeom prst="rect">
             <a:avLst/>
@@ -3340,13 +3372,13 @@
           <a:p>
             <a:pPr algn="ctr"/>
             <a:r>
-              <a:rPr sz="1100" b="0" i="0">
+              <a:rPr sz="1200" b="0" i="0">
                 <a:solidFill>
-                  <a:srgbClr val="6B6B8A"/>
+                  <a:srgbClr val="4A7FA5"/>
                 </a:solidFill>
                 <a:latin typeface="Calibri"/>
               </a:rPr>
-              <a:t>React  ·  Supabase  ·  Vercel  ·  Mobile-first  ·  Sin instalar nada</a:t>
+              <a:t>React  ·  Supabase  ·  Vercel  ·  Mobile-first</a:t>
             </a:r>
           </a:p>
         </p:txBody>
@@ -3365,7 +3397,7 @@
     <p:bg>
       <p:bgPr>
         <a:solidFill>
-          <a:srgbClr val="F4F6F9"/>
+          <a:srgbClr val="FFFFFF"/>
         </a:solidFill>
         <a:effectLst/>
       </p:bgPr>
@@ -3386,7 +3418,447 @@
         <p:spPr>
           <a:xfrm>
             <a:off x="0" y="0"/>
+            <a:ext cx="12188952" cy="73152"/>
+          </a:xfrm>
+          <a:prstGeom prst="rect">
+            <a:avLst/>
+          </a:prstGeom>
+          <a:solidFill>
+            <a:srgbClr val="016CB0"/>
+          </a:solidFill>
+          <a:ln>
+            <a:noFill/>
+          </a:ln>
+        </p:spPr>
+        <p:style>
+          <a:lnRef idx="1">
+            <a:schemeClr val="accent1"/>
+          </a:lnRef>
+          <a:fillRef idx="3">
+            <a:schemeClr val="accent1"/>
+          </a:fillRef>
+          <a:effectRef idx="2">
+            <a:schemeClr val="accent1"/>
+          </a:effectRef>
+          <a:fontRef idx="minor">
+            <a:schemeClr val="lt1"/>
+          </a:fontRef>
+        </p:style>
+        <p:txBody>
+          <a:bodyPr rtlCol="0" anchor="ctr"/>
+          <a:lstStyle/>
+          <a:p>
+            <a:pPr algn="ctr"/>
+          </a:p>
+        </p:txBody>
+      </p:sp>
+      <p:sp>
+        <p:nvSpPr>
+          <p:cNvPr id="3" name="Rectangle 2"/>
+          <p:cNvSpPr/>
+          <p:nvPr/>
+        </p:nvSpPr>
+        <p:spPr>
+          <a:xfrm>
+            <a:off x="0" y="0"/>
             <a:ext cx="164592" cy="6858000"/>
+          </a:xfrm>
+          <a:prstGeom prst="rect">
+            <a:avLst/>
+          </a:prstGeom>
+          <a:solidFill>
+            <a:srgbClr val="016CB0"/>
+          </a:solidFill>
+          <a:ln>
+            <a:noFill/>
+          </a:ln>
+        </p:spPr>
+        <p:style>
+          <a:lnRef idx="1">
+            <a:schemeClr val="accent1"/>
+          </a:lnRef>
+          <a:fillRef idx="3">
+            <a:schemeClr val="accent1"/>
+          </a:fillRef>
+          <a:effectRef idx="2">
+            <a:schemeClr val="accent1"/>
+          </a:effectRef>
+          <a:fontRef idx="minor">
+            <a:schemeClr val="lt1"/>
+          </a:fontRef>
+        </p:style>
+        <p:txBody>
+          <a:bodyPr rtlCol="0" anchor="ctr"/>
+          <a:lstStyle/>
+          <a:p>
+            <a:pPr algn="ctr"/>
+          </a:p>
+        </p:txBody>
+      </p:sp>
+      <p:sp>
+        <p:nvSpPr>
+          <p:cNvPr id="4" name="TextBox 3"/>
+          <p:cNvSpPr txBox="1"/>
+          <p:nvPr/>
+        </p:nvSpPr>
+        <p:spPr>
+          <a:xfrm>
+            <a:off x="411480" y="228600"/>
+            <a:ext cx="8229600" cy="365760"/>
+          </a:xfrm>
+          <a:prstGeom prst="rect">
+            <a:avLst/>
+          </a:prstGeom>
+          <a:noFill/>
+        </p:spPr>
+        <p:txBody>
+          <a:bodyPr wrap="square">
+            <a:spAutoFit/>
+          </a:bodyPr>
+          <a:lstStyle/>
+          <a:p>
+            <a:pPr algn="l"/>
+            <a:r>
+              <a:rPr sz="1100" b="1" i="0">
+                <a:solidFill>
+                  <a:srgbClr val="016CB0"/>
+                </a:solidFill>
+                <a:latin typeface="Calibri"/>
+              </a:rPr>
+              <a:t>EL PROBLEMA</a:t>
+            </a:r>
+          </a:p>
+        </p:txBody>
+      </p:sp>
+      <p:sp>
+        <p:nvSpPr>
+          <p:cNvPr id="5" name="TextBox 4"/>
+          <p:cNvSpPr txBox="1"/>
+          <p:nvPr/>
+        </p:nvSpPr>
+        <p:spPr>
+          <a:xfrm>
+            <a:off x="411480" y="685800"/>
+            <a:ext cx="8229600" cy="1645920"/>
+          </a:xfrm>
+          <a:prstGeom prst="rect">
+            <a:avLst/>
+          </a:prstGeom>
+          <a:noFill/>
+        </p:spPr>
+        <p:txBody>
+          <a:bodyPr wrap="square">
+            <a:spAutoFit/>
+          </a:bodyPr>
+          <a:lstStyle/>
+          <a:p>
+            <a:pPr algn="l"/>
+            <a:r>
+              <a:rPr sz="4400" b="1" i="0">
+                <a:solidFill>
+                  <a:srgbClr val="0A1E35"/>
+                </a:solidFill>
+                <a:latin typeface="Calibri"/>
+              </a:rPr>
+              <a:t>¿Cuándo fue el último
+cambio de aceite?</a:t>
+            </a:r>
+          </a:p>
+        </p:txBody>
+      </p:sp>
+      <p:sp>
+        <p:nvSpPr>
+          <p:cNvPr id="6" name="TextBox 5"/>
+          <p:cNvSpPr txBox="1"/>
+          <p:nvPr/>
+        </p:nvSpPr>
+        <p:spPr>
+          <a:xfrm>
+            <a:off x="411480" y="2514600"/>
+            <a:ext cx="8686800" cy="914400"/>
+          </a:xfrm>
+          <a:prstGeom prst="rect">
+            <a:avLst/>
+          </a:prstGeom>
+          <a:noFill/>
+        </p:spPr>
+        <p:txBody>
+          <a:bodyPr wrap="square">
+            <a:spAutoFit/>
+          </a:bodyPr>
+          <a:lstStyle/>
+          <a:p>
+            <a:pPr algn="l"/>
+            <a:r>
+              <a:rPr sz="1500" b="0" i="0">
+                <a:solidFill>
+                  <a:srgbClr val="3D6080"/>
+                </a:solidFill>
+                <a:latin typeface="Calibri"/>
+              </a:rPr>
+              <a:t>La mayoría de conductores lleva el mantenimiento de su coche
+con papeles perdidos, notas mentales o simplemente… no lo lleva.</a:t>
+            </a:r>
+          </a:p>
+        </p:txBody>
+      </p:sp>
+      <p:sp>
+        <p:nvSpPr>
+          <p:cNvPr id="7" name="Rectangle 6"/>
+          <p:cNvSpPr/>
+          <p:nvPr/>
+        </p:nvSpPr>
+        <p:spPr>
+          <a:xfrm>
+            <a:off x="411480" y="3657600"/>
+            <a:ext cx="3429000" cy="2148840"/>
+          </a:xfrm>
+          <a:prstGeom prst="rect">
+            <a:avLst/>
+          </a:prstGeom>
+          <a:solidFill>
+            <a:srgbClr val="F5FAFF"/>
+          </a:solidFill>
+          <a:ln w="12700">
+            <a:solidFill>
+              <a:srgbClr val="C5DDEF"/>
+            </a:solidFill>
+          </a:ln>
+        </p:spPr>
+        <p:style>
+          <a:lnRef idx="1">
+            <a:schemeClr val="accent1"/>
+          </a:lnRef>
+          <a:fillRef idx="3">
+            <a:schemeClr val="accent1"/>
+          </a:fillRef>
+          <a:effectRef idx="2">
+            <a:schemeClr val="accent1"/>
+          </a:effectRef>
+          <a:fontRef idx="minor">
+            <a:schemeClr val="lt1"/>
+          </a:fontRef>
+        </p:style>
+        <p:txBody>
+          <a:bodyPr rtlCol="0" anchor="ctr"/>
+          <a:lstStyle/>
+          <a:p>
+            <a:pPr algn="ctr"/>
+          </a:p>
+        </p:txBody>
+      </p:sp>
+      <p:sp>
+        <p:nvSpPr>
+          <p:cNvPr id="8" name="Rectangle 7"/>
+          <p:cNvSpPr/>
+          <p:nvPr/>
+        </p:nvSpPr>
+        <p:spPr>
+          <a:xfrm>
+            <a:off x="411480" y="3657600"/>
+            <a:ext cx="3429000" cy="109728"/>
+          </a:xfrm>
+          <a:prstGeom prst="rect">
+            <a:avLst/>
+          </a:prstGeom>
+          <a:solidFill>
+            <a:srgbClr val="E8453C"/>
+          </a:solidFill>
+          <a:ln>
+            <a:noFill/>
+          </a:ln>
+        </p:spPr>
+        <p:style>
+          <a:lnRef idx="1">
+            <a:schemeClr val="accent1"/>
+          </a:lnRef>
+          <a:fillRef idx="3">
+            <a:schemeClr val="accent1"/>
+          </a:fillRef>
+          <a:effectRef idx="2">
+            <a:schemeClr val="accent1"/>
+          </a:effectRef>
+          <a:fontRef idx="minor">
+            <a:schemeClr val="lt1"/>
+          </a:fontRef>
+        </p:style>
+        <p:txBody>
+          <a:bodyPr rtlCol="0" anchor="ctr"/>
+          <a:lstStyle/>
+          <a:p>
+            <a:pPr algn="ctr"/>
+          </a:p>
+        </p:txBody>
+      </p:sp>
+      <p:sp>
+        <p:nvSpPr>
+          <p:cNvPr id="9" name="Oval 8"/>
+          <p:cNvSpPr/>
+          <p:nvPr/>
+        </p:nvSpPr>
+        <p:spPr>
+          <a:xfrm>
+            <a:off x="612648" y="3913632"/>
+            <a:ext cx="384048" cy="384048"/>
+          </a:xfrm>
+          <a:prstGeom prst="ellipse">
+            <a:avLst/>
+          </a:prstGeom>
+          <a:solidFill>
+            <a:srgbClr val="E8453C"/>
+          </a:solidFill>
+          <a:ln>
+            <a:noFill/>
+          </a:ln>
+        </p:spPr>
+        <p:style>
+          <a:lnRef idx="1">
+            <a:schemeClr val="accent1"/>
+          </a:lnRef>
+          <a:fillRef idx="3">
+            <a:schemeClr val="accent1"/>
+          </a:fillRef>
+          <a:effectRef idx="2">
+            <a:schemeClr val="accent1"/>
+          </a:effectRef>
+          <a:fontRef idx="minor">
+            <a:schemeClr val="lt1"/>
+          </a:fontRef>
+        </p:style>
+        <p:txBody>
+          <a:bodyPr rtlCol="0" anchor="ctr"/>
+          <a:lstStyle/>
+          <a:p>
+            <a:pPr algn="ctr"/>
+          </a:p>
+        </p:txBody>
+      </p:sp>
+      <p:sp>
+        <p:nvSpPr>
+          <p:cNvPr id="10" name="TextBox 9"/>
+          <p:cNvSpPr txBox="1"/>
+          <p:nvPr/>
+        </p:nvSpPr>
+        <p:spPr>
+          <a:xfrm>
+            <a:off x="1161288" y="3904487"/>
+            <a:ext cx="2514600" cy="411480"/>
+          </a:xfrm>
+          <a:prstGeom prst="rect">
+            <a:avLst/>
+          </a:prstGeom>
+          <a:noFill/>
+        </p:spPr>
+        <p:txBody>
+          <a:bodyPr wrap="square">
+            <a:spAutoFit/>
+          </a:bodyPr>
+          <a:lstStyle/>
+          <a:p>
+            <a:pPr algn="l"/>
+            <a:r>
+              <a:rPr sz="1500" b="1" i="0">
+                <a:solidFill>
+                  <a:srgbClr val="0A1E35"/>
+                </a:solidFill>
+                <a:latin typeface="Calibri"/>
+              </a:rPr>
+              <a:t>Olvidan revisiones</a:t>
+            </a:r>
+          </a:p>
+        </p:txBody>
+      </p:sp>
+      <p:sp>
+        <p:nvSpPr>
+          <p:cNvPr id="11" name="TextBox 10"/>
+          <p:cNvSpPr txBox="1"/>
+          <p:nvPr/>
+        </p:nvSpPr>
+        <p:spPr>
+          <a:xfrm>
+            <a:off x="576072" y="4434840"/>
+            <a:ext cx="3108960" cy="1097280"/>
+          </a:xfrm>
+          <a:prstGeom prst="rect">
+            <a:avLst/>
+          </a:prstGeom>
+          <a:noFill/>
+        </p:spPr>
+        <p:txBody>
+          <a:bodyPr wrap="square">
+            <a:spAutoFit/>
+          </a:bodyPr>
+          <a:lstStyle/>
+          <a:p>
+            <a:pPr algn="l"/>
+            <a:r>
+              <a:rPr sz="1300" b="0" i="0">
+                <a:solidFill>
+                  <a:srgbClr val="3D6080"/>
+                </a:solidFill>
+                <a:latin typeface="Calibri"/>
+              </a:rPr>
+              <a:t>ITV vencida, multas,
+averías inesperadas.</a:t>
+            </a:r>
+          </a:p>
+        </p:txBody>
+      </p:sp>
+      <p:sp>
+        <p:nvSpPr>
+          <p:cNvPr id="12" name="Rectangle 11"/>
+          <p:cNvSpPr/>
+          <p:nvPr/>
+        </p:nvSpPr>
+        <p:spPr>
+          <a:xfrm>
+            <a:off x="4187952" y="3657600"/>
+            <a:ext cx="3429000" cy="2148840"/>
+          </a:xfrm>
+          <a:prstGeom prst="rect">
+            <a:avLst/>
+          </a:prstGeom>
+          <a:solidFill>
+            <a:srgbClr val="F5FAFF"/>
+          </a:solidFill>
+          <a:ln w="12700">
+            <a:solidFill>
+              <a:srgbClr val="C5DDEF"/>
+            </a:solidFill>
+          </a:ln>
+        </p:spPr>
+        <p:style>
+          <a:lnRef idx="1">
+            <a:schemeClr val="accent1"/>
+          </a:lnRef>
+          <a:fillRef idx="3">
+            <a:schemeClr val="accent1"/>
+          </a:fillRef>
+          <a:effectRef idx="2">
+            <a:schemeClr val="accent1"/>
+          </a:effectRef>
+          <a:fontRef idx="minor">
+            <a:schemeClr val="lt1"/>
+          </a:fontRef>
+        </p:style>
+        <p:txBody>
+          <a:bodyPr rtlCol="0" anchor="ctr"/>
+          <a:lstStyle/>
+          <a:p>
+            <a:pPr algn="ctr"/>
+          </a:p>
+        </p:txBody>
+      </p:sp>
+      <p:sp>
+        <p:nvSpPr>
+          <p:cNvPr id="13" name="Rectangle 12"/>
+          <p:cNvSpPr/>
+          <p:nvPr/>
+        </p:nvSpPr>
+        <p:spPr>
+          <a:xfrm>
+            <a:off x="4187952" y="3657600"/>
+            <a:ext cx="3429000" cy="109728"/>
           </a:xfrm>
           <a:prstGeom prst="rect">
             <a:avLst/>
@@ -3422,132 +3894,23 @@
       </p:sp>
       <p:sp>
         <p:nvSpPr>
-          <p:cNvPr id="3" name="TextBox 2"/>
-          <p:cNvSpPr txBox="1"/>
-          <p:nvPr/>
-        </p:nvSpPr>
-        <p:spPr>
-          <a:xfrm>
-            <a:off x="457200" y="320040"/>
-            <a:ext cx="8229600" cy="411480"/>
-          </a:xfrm>
-          <a:prstGeom prst="rect">
-            <a:avLst/>
-          </a:prstGeom>
-          <a:noFill/>
-        </p:spPr>
-        <p:txBody>
-          <a:bodyPr wrap="square">
-            <a:spAutoFit/>
-          </a:bodyPr>
-          <a:lstStyle/>
-          <a:p>
-            <a:pPr algn="l"/>
-            <a:r>
-              <a:rPr sz="1200" b="1" i="0">
-                <a:solidFill>
-                  <a:srgbClr val="F5A623"/>
-                </a:solidFill>
-                <a:latin typeface="Calibri"/>
-              </a:rPr>
-              <a:t>EL PROBLEMA</a:t>
-            </a:r>
-          </a:p>
-        </p:txBody>
-      </p:sp>
-      <p:sp>
-        <p:nvSpPr>
-          <p:cNvPr id="4" name="TextBox 3"/>
-          <p:cNvSpPr txBox="1"/>
-          <p:nvPr/>
-        </p:nvSpPr>
-        <p:spPr>
-          <a:xfrm>
-            <a:off x="457200" y="822960"/>
-            <a:ext cx="8229600" cy="1645920"/>
-          </a:xfrm>
-          <a:prstGeom prst="rect">
-            <a:avLst/>
-          </a:prstGeom>
-          <a:noFill/>
-        </p:spPr>
-        <p:txBody>
-          <a:bodyPr wrap="square">
-            <a:spAutoFit/>
-          </a:bodyPr>
-          <a:lstStyle/>
-          <a:p>
-            <a:pPr algn="l"/>
-            <a:r>
-              <a:rPr sz="4400" b="1" i="0">
-                <a:solidFill>
-                  <a:srgbClr val="1C1C2E"/>
-                </a:solidFill>
-                <a:latin typeface="Calibri"/>
-              </a:rPr>
-              <a:t>¿Cuándo fue el último
-cambio de aceite?</a:t>
-            </a:r>
-          </a:p>
-        </p:txBody>
-      </p:sp>
-      <p:sp>
-        <p:nvSpPr>
-          <p:cNvPr id="5" name="TextBox 4"/>
-          <p:cNvSpPr txBox="1"/>
-          <p:nvPr/>
-        </p:nvSpPr>
-        <p:spPr>
-          <a:xfrm>
-            <a:off x="457200" y="2606040"/>
-            <a:ext cx="8686800" cy="914400"/>
-          </a:xfrm>
-          <a:prstGeom prst="rect">
-            <a:avLst/>
-          </a:prstGeom>
-          <a:noFill/>
-        </p:spPr>
-        <p:txBody>
-          <a:bodyPr wrap="square">
-            <a:spAutoFit/>
-          </a:bodyPr>
-          <a:lstStyle/>
-          <a:p>
-            <a:pPr algn="l"/>
-            <a:r>
-              <a:rPr sz="1600" b="0" i="0">
-                <a:solidFill>
-                  <a:srgbClr val="4A5568"/>
-                </a:solidFill>
-                <a:latin typeface="Calibri"/>
-              </a:rPr>
-              <a:t>La mayoría de conductores gestiona el mantenimiento de su coche
-con papeles perdidos, notas mentales o simplemente… no lo gestiona.</a:t>
-            </a:r>
-          </a:p>
-        </p:txBody>
-      </p:sp>
-      <p:sp>
-        <p:nvSpPr>
-          <p:cNvPr id="6" name="Rectangle 5"/>
+          <p:cNvPr id="14" name="Oval 13"/>
           <p:cNvSpPr/>
           <p:nvPr/>
         </p:nvSpPr>
         <p:spPr>
           <a:xfrm>
-            <a:off x="457200" y="3840480"/>
-            <a:ext cx="3383280" cy="1920240"/>
-          </a:xfrm>
-          <a:prstGeom prst="rect">
+            <a:off x="4389120" y="3913632"/>
+            <a:ext cx="384048" cy="384048"/>
+          </a:xfrm>
+          <a:prstGeom prst="ellipse">
             <a:avLst/>
           </a:prstGeom>
           <a:solidFill>
-            <a:srgbClr val="FFFFFF"/>
+            <a:srgbClr val="F5A623"/>
           </a:solidFill>
-          <a:ln w="12700">
-            <a:solidFill>
-              <a:srgbClr val="E2E8F0"/>
-            </a:solidFill>
+          <a:ln>
+            <a:noFill/>
           </a:ln>
         </p:spPr>
         <p:style>
@@ -3574,14 +3937,14 @@
       </p:sp>
       <p:sp>
         <p:nvSpPr>
-          <p:cNvPr id="7" name="TextBox 6"/>
+          <p:cNvPr id="15" name="TextBox 14"/>
           <p:cNvSpPr txBox="1"/>
           <p:nvPr/>
         </p:nvSpPr>
         <p:spPr>
           <a:xfrm>
-            <a:off x="594360" y="3977640"/>
-            <a:ext cx="640080" cy="548640"/>
+            <a:off x="4937760" y="3904487"/>
+            <a:ext cx="2514600" cy="411480"/>
           </a:xfrm>
           <a:prstGeom prst="rect">
             <a:avLst/>
@@ -3596,27 +3959,27 @@
           <a:p>
             <a:pPr algn="l"/>
             <a:r>
-              <a:rPr sz="2200" b="0" i="0">
+              <a:rPr sz="1500" b="1" i="0">
                 <a:solidFill>
-                  <a:srgbClr val="1C1C2E"/>
+                  <a:srgbClr val="0A1E35"/>
                 </a:solidFill>
                 <a:latin typeface="Calibri"/>
               </a:rPr>
-              <a:t>🔴</a:t>
-            </a:r>
-          </a:p>
-        </p:txBody>
-      </p:sp>
-      <p:sp>
-        <p:nvSpPr>
-          <p:cNvPr id="8" name="TextBox 7"/>
+              <a:t>Sin historial claro</a:t>
+            </a:r>
+          </a:p>
+        </p:txBody>
+      </p:sp>
+      <p:sp>
+        <p:nvSpPr>
+          <p:cNvPr id="16" name="TextBox 15"/>
           <p:cNvSpPr txBox="1"/>
           <p:nvPr/>
         </p:nvSpPr>
         <p:spPr>
           <a:xfrm>
-            <a:off x="594360" y="4480560"/>
-            <a:ext cx="3108960" cy="411480"/>
+            <a:off x="4352544" y="4434840"/>
+            <a:ext cx="3108960" cy="1097280"/>
           </a:xfrm>
           <a:prstGeom prst="rect">
             <a:avLst/>
@@ -3631,72 +3994,38 @@
           <a:p>
             <a:pPr algn="l"/>
             <a:r>
-              <a:rPr sz="1600" b="1" i="0">
+              <a:rPr sz="1300" b="0" i="0">
                 <a:solidFill>
-                  <a:srgbClr val="1C1C2E"/>
+                  <a:srgbClr val="3D6080"/>
                 </a:solidFill>
                 <a:latin typeface="Calibri"/>
               </a:rPr>
-              <a:t>Olvidan revisiones</a:t>
-            </a:r>
-          </a:p>
-        </p:txBody>
-      </p:sp>
-      <p:sp>
-        <p:nvSpPr>
-          <p:cNvPr id="9" name="TextBox 8"/>
-          <p:cNvSpPr txBox="1"/>
-          <p:nvPr/>
-        </p:nvSpPr>
-        <p:spPr>
-          <a:xfrm>
-            <a:off x="594360" y="4846320"/>
-            <a:ext cx="3108960" cy="640080"/>
-          </a:xfrm>
-          <a:prstGeom prst="rect">
-            <a:avLst/>
-          </a:prstGeom>
-          <a:noFill/>
-        </p:spPr>
-        <p:txBody>
-          <a:bodyPr wrap="square">
-            <a:spAutoFit/>
-          </a:bodyPr>
-          <a:lstStyle/>
-          <a:p>
-            <a:pPr algn="l"/>
-            <a:r>
-              <a:rPr sz="1200" b="0" i="0">
-                <a:solidFill>
-                  <a:srgbClr val="4A5568"/>
-                </a:solidFill>
-                <a:latin typeface="Calibri"/>
-              </a:rPr>
-              <a:t>ITV vencida, multas, averías inesperadas</a:t>
-            </a:r>
-          </a:p>
-        </p:txBody>
-      </p:sp>
-      <p:sp>
-        <p:nvSpPr>
-          <p:cNvPr id="10" name="Rectangle 9"/>
+              <a:t>Papel perdido, notas
+dispersas, sin orden.</a:t>
+            </a:r>
+          </a:p>
+        </p:txBody>
+      </p:sp>
+      <p:sp>
+        <p:nvSpPr>
+          <p:cNvPr id="17" name="Rectangle 16"/>
           <p:cNvSpPr/>
           <p:nvPr/>
         </p:nvSpPr>
         <p:spPr>
           <a:xfrm>
-            <a:off x="4315968" y="3840480"/>
-            <a:ext cx="3383280" cy="1920240"/>
+            <a:off x="7964424" y="3657600"/>
+            <a:ext cx="3429000" cy="2148840"/>
           </a:xfrm>
           <a:prstGeom prst="rect">
             <a:avLst/>
           </a:prstGeom>
           <a:solidFill>
-            <a:srgbClr val="FFFFFF"/>
+            <a:srgbClr val="F5FAFF"/>
           </a:solidFill>
           <a:ln w="12700">
             <a:solidFill>
-              <a:srgbClr val="E2E8F0"/>
+              <a:srgbClr val="C5DDEF"/>
             </a:solidFill>
           </a:ln>
         </p:spPr>
@@ -3724,130 +4053,23 @@
       </p:sp>
       <p:sp>
         <p:nvSpPr>
-          <p:cNvPr id="11" name="TextBox 10"/>
-          <p:cNvSpPr txBox="1"/>
-          <p:nvPr/>
-        </p:nvSpPr>
-        <p:spPr>
-          <a:xfrm>
-            <a:off x="4453128" y="3977640"/>
-            <a:ext cx="640080" cy="548640"/>
-          </a:xfrm>
-          <a:prstGeom prst="rect">
-            <a:avLst/>
-          </a:prstGeom>
-          <a:noFill/>
-        </p:spPr>
-        <p:txBody>
-          <a:bodyPr wrap="square">
-            <a:spAutoFit/>
-          </a:bodyPr>
-          <a:lstStyle/>
-          <a:p>
-            <a:pPr algn="l"/>
-            <a:r>
-              <a:rPr sz="2200" b="0" i="0">
-                <a:solidFill>
-                  <a:srgbClr val="1C1C2E"/>
-                </a:solidFill>
-                <a:latin typeface="Calibri"/>
-              </a:rPr>
-              <a:t>🟡</a:t>
-            </a:r>
-          </a:p>
-        </p:txBody>
-      </p:sp>
-      <p:sp>
-        <p:nvSpPr>
-          <p:cNvPr id="12" name="TextBox 11"/>
-          <p:cNvSpPr txBox="1"/>
-          <p:nvPr/>
-        </p:nvSpPr>
-        <p:spPr>
-          <a:xfrm>
-            <a:off x="4453128" y="4480560"/>
-            <a:ext cx="3108960" cy="411480"/>
-          </a:xfrm>
-          <a:prstGeom prst="rect">
-            <a:avLst/>
-          </a:prstGeom>
-          <a:noFill/>
-        </p:spPr>
-        <p:txBody>
-          <a:bodyPr wrap="square">
-            <a:spAutoFit/>
-          </a:bodyPr>
-          <a:lstStyle/>
-          <a:p>
-            <a:pPr algn="l"/>
-            <a:r>
-              <a:rPr sz="1600" b="1" i="0">
-                <a:solidFill>
-                  <a:srgbClr val="1C1C2E"/>
-                </a:solidFill>
-                <a:latin typeface="Calibri"/>
-              </a:rPr>
-              <a:t>Sin historial claro</a:t>
-            </a:r>
-          </a:p>
-        </p:txBody>
-      </p:sp>
-      <p:sp>
-        <p:nvSpPr>
-          <p:cNvPr id="13" name="TextBox 12"/>
-          <p:cNvSpPr txBox="1"/>
-          <p:nvPr/>
-        </p:nvSpPr>
-        <p:spPr>
-          <a:xfrm>
-            <a:off x="4453128" y="4846320"/>
-            <a:ext cx="3108960" cy="640080"/>
-          </a:xfrm>
-          <a:prstGeom prst="rect">
-            <a:avLst/>
-          </a:prstGeom>
-          <a:noFill/>
-        </p:spPr>
-        <p:txBody>
-          <a:bodyPr wrap="square">
-            <a:spAutoFit/>
-          </a:bodyPr>
-          <a:lstStyle/>
-          <a:p>
-            <a:pPr algn="l"/>
-            <a:r>
-              <a:rPr sz="1200" b="0" i="0">
-                <a:solidFill>
-                  <a:srgbClr val="4A5568"/>
-                </a:solidFill>
-                <a:latin typeface="Calibri"/>
-              </a:rPr>
-              <a:t>Papel perdido, notas dispersas, memoria</a:t>
-            </a:r>
-          </a:p>
-        </p:txBody>
-      </p:sp>
-      <p:sp>
-        <p:nvSpPr>
-          <p:cNvPr id="14" name="Rectangle 13"/>
+          <p:cNvPr id="18" name="Rectangle 17"/>
           <p:cNvSpPr/>
           <p:nvPr/>
         </p:nvSpPr>
         <p:spPr>
           <a:xfrm>
-            <a:off x="8174736" y="3840480"/>
-            <a:ext cx="3383280" cy="1920240"/>
+            <a:off x="7964424" y="3657600"/>
+            <a:ext cx="3429000" cy="109728"/>
           </a:xfrm>
           <a:prstGeom prst="rect">
             <a:avLst/>
           </a:prstGeom>
           <a:solidFill>
-            <a:srgbClr val="FFFFFF"/>
+            <a:srgbClr val="016CB0"/>
           </a:solidFill>
-          <a:ln w="12700">
-            <a:solidFill>
-              <a:srgbClr val="E2E8F0"/>
-            </a:solidFill>
+          <a:ln>
+            <a:noFill/>
           </a:ln>
         </p:spPr>
         <p:style>
@@ -3874,14 +4096,57 @@
       </p:sp>
       <p:sp>
         <p:nvSpPr>
-          <p:cNvPr id="15" name="TextBox 14"/>
+          <p:cNvPr id="19" name="Oval 18"/>
+          <p:cNvSpPr/>
+          <p:nvPr/>
+        </p:nvSpPr>
+        <p:spPr>
+          <a:xfrm>
+            <a:off x="8165592" y="3913632"/>
+            <a:ext cx="384048" cy="384048"/>
+          </a:xfrm>
+          <a:prstGeom prst="ellipse">
+            <a:avLst/>
+          </a:prstGeom>
+          <a:solidFill>
+            <a:srgbClr val="016CB0"/>
+          </a:solidFill>
+          <a:ln>
+            <a:noFill/>
+          </a:ln>
+        </p:spPr>
+        <p:style>
+          <a:lnRef idx="1">
+            <a:schemeClr val="accent1"/>
+          </a:lnRef>
+          <a:fillRef idx="3">
+            <a:schemeClr val="accent1"/>
+          </a:fillRef>
+          <a:effectRef idx="2">
+            <a:schemeClr val="accent1"/>
+          </a:effectRef>
+          <a:fontRef idx="minor">
+            <a:schemeClr val="lt1"/>
+          </a:fontRef>
+        </p:style>
+        <p:txBody>
+          <a:bodyPr rtlCol="0" anchor="ctr"/>
+          <a:lstStyle/>
+          <a:p>
+            <a:pPr algn="ctr"/>
+          </a:p>
+        </p:txBody>
+      </p:sp>
+      <p:sp>
+        <p:nvSpPr>
+          <p:cNvPr id="20" name="TextBox 19"/>
           <p:cNvSpPr txBox="1"/>
           <p:nvPr/>
         </p:nvSpPr>
         <p:spPr>
           <a:xfrm>
-            <a:off x="8311896" y="3977640"/>
-            <a:ext cx="640080" cy="548640"/>
+            <a:off x="8714232" y="3904487"/>
+            <a:ext cx="2514600" cy="411480"/>
           </a:xfrm>
           <a:prstGeom prst="rect">
             <a:avLst/>
@@ -3896,44 +4161,9 @@
           <a:p>
             <a:pPr algn="l"/>
             <a:r>
-              <a:rPr sz="2200" b="0" i="0">
+              <a:rPr sz="1500" b="1" i="0">
                 <a:solidFill>
-                  <a:srgbClr val="1C1C2E"/>
-                </a:solidFill>
-                <a:latin typeface="Calibri"/>
-              </a:rPr>
-              <a:t>⚠️</a:t>
-            </a:r>
-          </a:p>
-        </p:txBody>
-      </p:sp>
-      <p:sp>
-        <p:nvSpPr>
-          <p:cNvPr id="16" name="TextBox 15"/>
-          <p:cNvSpPr txBox="1"/>
-          <p:nvPr/>
-        </p:nvSpPr>
-        <p:spPr>
-          <a:xfrm>
-            <a:off x="8311896" y="4480560"/>
-            <a:ext cx="3108960" cy="411480"/>
-          </a:xfrm>
-          <a:prstGeom prst="rect">
-            <a:avLst/>
-          </a:prstGeom>
-          <a:noFill/>
-        </p:spPr>
-        <p:txBody>
-          <a:bodyPr wrap="square">
-            <a:spAutoFit/>
-          </a:bodyPr>
-          <a:lstStyle/>
-          <a:p>
-            <a:pPr algn="l"/>
-            <a:r>
-              <a:rPr sz="1600" b="1" i="0">
-                <a:solidFill>
-                  <a:srgbClr val="1C1C2E"/>
+                  <a:srgbClr val="0A1E35"/>
                 </a:solidFill>
                 <a:latin typeface="Calibri"/>
               </a:rPr>
@@ -3944,14 +4174,14 @@
       </p:sp>
       <p:sp>
         <p:nvSpPr>
-          <p:cNvPr id="17" name="TextBox 16"/>
+          <p:cNvPr id="21" name="TextBox 20"/>
           <p:cNvSpPr txBox="1"/>
           <p:nvPr/>
         </p:nvSpPr>
         <p:spPr>
           <a:xfrm>
-            <a:off x="8311896" y="4846320"/>
-            <a:ext cx="3108960" cy="640080"/>
+            <a:off x="8129016" y="4434840"/>
+            <a:ext cx="3108960" cy="1097280"/>
           </a:xfrm>
           <a:prstGeom prst="rect">
             <a:avLst/>
@@ -3966,13 +4196,14 @@
           <a:p>
             <a:pPr algn="l"/>
             <a:r>
-              <a:rPr sz="1200" b="0" i="0">
+              <a:rPr sz="1300" b="0" i="0">
                 <a:solidFill>
-                  <a:srgbClr val="4A5568"/>
+                  <a:srgbClr val="3D6080"/>
                 </a:solidFill>
                 <a:latin typeface="Calibri"/>
               </a:rPr>
-              <a:t>Nadie avisa cuando algo está a punto de vencer</a:t>
+              <a:t>Nadie avisa cuando
+algo está por vencer.</a:t>
             </a:r>
           </a:p>
         </p:txBody>
@@ -3991,7 +4222,7 @@
     <p:bg>
       <p:bgPr>
         <a:solidFill>
-          <a:srgbClr val="F4F6F9"/>
+          <a:srgbClr val="FFFFFF"/>
         </a:solidFill>
         <a:effectLst/>
       </p:bgPr>
@@ -4012,7 +4243,446 @@
         <p:spPr>
           <a:xfrm>
             <a:off x="0" y="0"/>
+            <a:ext cx="12188952" cy="73152"/>
+          </a:xfrm>
+          <a:prstGeom prst="rect">
+            <a:avLst/>
+          </a:prstGeom>
+          <a:solidFill>
+            <a:srgbClr val="016CB0"/>
+          </a:solidFill>
+          <a:ln>
+            <a:noFill/>
+          </a:ln>
+        </p:spPr>
+        <p:style>
+          <a:lnRef idx="1">
+            <a:schemeClr val="accent1"/>
+          </a:lnRef>
+          <a:fillRef idx="3">
+            <a:schemeClr val="accent1"/>
+          </a:fillRef>
+          <a:effectRef idx="2">
+            <a:schemeClr val="accent1"/>
+          </a:effectRef>
+          <a:fontRef idx="minor">
+            <a:schemeClr val="lt1"/>
+          </a:fontRef>
+        </p:style>
+        <p:txBody>
+          <a:bodyPr rtlCol="0" anchor="ctr"/>
+          <a:lstStyle/>
+          <a:p>
+            <a:pPr algn="ctr"/>
+          </a:p>
+        </p:txBody>
+      </p:sp>
+      <p:sp>
+        <p:nvSpPr>
+          <p:cNvPr id="3" name="Rectangle 2"/>
+          <p:cNvSpPr/>
+          <p:nvPr/>
+        </p:nvSpPr>
+        <p:spPr>
+          <a:xfrm>
+            <a:off x="0" y="0"/>
             <a:ext cx="164592" cy="6858000"/>
+          </a:xfrm>
+          <a:prstGeom prst="rect">
+            <a:avLst/>
+          </a:prstGeom>
+          <a:solidFill>
+            <a:srgbClr val="016CB0"/>
+          </a:solidFill>
+          <a:ln>
+            <a:noFill/>
+          </a:ln>
+        </p:spPr>
+        <p:style>
+          <a:lnRef idx="1">
+            <a:schemeClr val="accent1"/>
+          </a:lnRef>
+          <a:fillRef idx="3">
+            <a:schemeClr val="accent1"/>
+          </a:fillRef>
+          <a:effectRef idx="2">
+            <a:schemeClr val="accent1"/>
+          </a:effectRef>
+          <a:fontRef idx="minor">
+            <a:schemeClr val="lt1"/>
+          </a:fontRef>
+        </p:style>
+        <p:txBody>
+          <a:bodyPr rtlCol="0" anchor="ctr"/>
+          <a:lstStyle/>
+          <a:p>
+            <a:pPr algn="ctr"/>
+          </a:p>
+        </p:txBody>
+      </p:sp>
+      <p:sp>
+        <p:nvSpPr>
+          <p:cNvPr id="4" name="TextBox 3"/>
+          <p:cNvSpPr txBox="1"/>
+          <p:nvPr/>
+        </p:nvSpPr>
+        <p:spPr>
+          <a:xfrm>
+            <a:off x="411480" y="228600"/>
+            <a:ext cx="8229600" cy="365760"/>
+          </a:xfrm>
+          <a:prstGeom prst="rect">
+            <a:avLst/>
+          </a:prstGeom>
+          <a:noFill/>
+        </p:spPr>
+        <p:txBody>
+          <a:bodyPr wrap="square">
+            <a:spAutoFit/>
+          </a:bodyPr>
+          <a:lstStyle/>
+          <a:p>
+            <a:pPr algn="l"/>
+            <a:r>
+              <a:rPr sz="1100" b="1" i="0">
+                <a:solidFill>
+                  <a:srgbClr val="016CB0"/>
+                </a:solidFill>
+                <a:latin typeface="Calibri"/>
+              </a:rPr>
+              <a:t>LA SOLUCIÓN</a:t>
+            </a:r>
+          </a:p>
+        </p:txBody>
+      </p:sp>
+      <p:sp>
+        <p:nvSpPr>
+          <p:cNvPr id="5" name="TextBox 4"/>
+          <p:cNvSpPr txBox="1"/>
+          <p:nvPr/>
+        </p:nvSpPr>
+        <p:spPr>
+          <a:xfrm>
+            <a:off x="411480" y="685800"/>
+            <a:ext cx="8686800" cy="1463040"/>
+          </a:xfrm>
+          <a:prstGeom prst="rect">
+            <a:avLst/>
+          </a:prstGeom>
+          <a:noFill/>
+        </p:spPr>
+        <p:txBody>
+          <a:bodyPr wrap="square">
+            <a:spAutoFit/>
+          </a:bodyPr>
+          <a:lstStyle/>
+          <a:p>
+            <a:pPr algn="l"/>
+            <a:r>
+              <a:rPr sz="3800" b="1" i="0">
+                <a:solidFill>
+                  <a:srgbClr val="0A1E35"/>
+                </a:solidFill>
+                <a:latin typeface="Calibri"/>
+              </a:rPr>
+              <a:t>Una app web mobile-first para llevar
+el control total de tus vehículos.</a:t>
+            </a:r>
+          </a:p>
+        </p:txBody>
+      </p:sp>
+      <p:sp>
+        <p:nvSpPr>
+          <p:cNvPr id="6" name="Rectangle 5"/>
+          <p:cNvSpPr/>
+          <p:nvPr/>
+        </p:nvSpPr>
+        <p:spPr>
+          <a:xfrm>
+            <a:off x="411480" y="2468880"/>
+            <a:ext cx="3429000" cy="3337560"/>
+          </a:xfrm>
+          <a:prstGeom prst="rect">
+            <a:avLst/>
+          </a:prstGeom>
+          <a:solidFill>
+            <a:srgbClr val="F5FAFF"/>
+          </a:solidFill>
+          <a:ln w="12700">
+            <a:solidFill>
+              <a:srgbClr val="C5DDEF"/>
+            </a:solidFill>
+          </a:ln>
+        </p:spPr>
+        <p:style>
+          <a:lnRef idx="1">
+            <a:schemeClr val="accent1"/>
+          </a:lnRef>
+          <a:fillRef idx="3">
+            <a:schemeClr val="accent1"/>
+          </a:fillRef>
+          <a:effectRef idx="2">
+            <a:schemeClr val="accent1"/>
+          </a:effectRef>
+          <a:fontRef idx="minor">
+            <a:schemeClr val="lt1"/>
+          </a:fontRef>
+        </p:style>
+        <p:txBody>
+          <a:bodyPr rtlCol="0" anchor="ctr"/>
+          <a:lstStyle/>
+          <a:p>
+            <a:pPr algn="ctr"/>
+          </a:p>
+        </p:txBody>
+      </p:sp>
+      <p:sp>
+        <p:nvSpPr>
+          <p:cNvPr id="7" name="Rectangle 6"/>
+          <p:cNvSpPr/>
+          <p:nvPr/>
+        </p:nvSpPr>
+        <p:spPr>
+          <a:xfrm>
+            <a:off x="411480" y="2468880"/>
+            <a:ext cx="3429000" cy="128016"/>
+          </a:xfrm>
+          <a:prstGeom prst="rect">
+            <a:avLst/>
+          </a:prstGeom>
+          <a:solidFill>
+            <a:srgbClr val="1DB954"/>
+          </a:solidFill>
+          <a:ln>
+            <a:noFill/>
+          </a:ln>
+        </p:spPr>
+        <p:style>
+          <a:lnRef idx="1">
+            <a:schemeClr val="accent1"/>
+          </a:lnRef>
+          <a:fillRef idx="3">
+            <a:schemeClr val="accent1"/>
+          </a:fillRef>
+          <a:effectRef idx="2">
+            <a:schemeClr val="accent1"/>
+          </a:effectRef>
+          <a:fontRef idx="minor">
+            <a:schemeClr val="lt1"/>
+          </a:fontRef>
+        </p:style>
+        <p:txBody>
+          <a:bodyPr rtlCol="0" anchor="ctr"/>
+          <a:lstStyle/>
+          <a:p>
+            <a:pPr algn="ctr"/>
+          </a:p>
+        </p:txBody>
+      </p:sp>
+      <p:sp>
+        <p:nvSpPr>
+          <p:cNvPr id="8" name="Oval 7"/>
+          <p:cNvSpPr/>
+          <p:nvPr/>
+        </p:nvSpPr>
+        <p:spPr>
+          <a:xfrm>
+            <a:off x="612648" y="2761488"/>
+            <a:ext cx="502920" cy="502920"/>
+          </a:xfrm>
+          <a:prstGeom prst="ellipse">
+            <a:avLst/>
+          </a:prstGeom>
+          <a:solidFill>
+            <a:srgbClr val="1DB954"/>
+          </a:solidFill>
+          <a:ln>
+            <a:noFill/>
+          </a:ln>
+        </p:spPr>
+        <p:style>
+          <a:lnRef idx="1">
+            <a:schemeClr val="accent1"/>
+          </a:lnRef>
+          <a:fillRef idx="3">
+            <a:schemeClr val="accent1"/>
+          </a:fillRef>
+          <a:effectRef idx="2">
+            <a:schemeClr val="accent1"/>
+          </a:effectRef>
+          <a:fontRef idx="minor">
+            <a:schemeClr val="lt1"/>
+          </a:fontRef>
+        </p:style>
+        <p:txBody>
+          <a:bodyPr rtlCol="0" anchor="ctr"/>
+          <a:lstStyle/>
+          <a:p>
+            <a:pPr algn="ctr"/>
+          </a:p>
+        </p:txBody>
+      </p:sp>
+      <p:sp>
+        <p:nvSpPr>
+          <p:cNvPr id="9" name="TextBox 8"/>
+          <p:cNvSpPr txBox="1"/>
+          <p:nvPr/>
+        </p:nvSpPr>
+        <p:spPr>
+          <a:xfrm>
+            <a:off x="612648" y="2761488"/>
+            <a:ext cx="502920" cy="502920"/>
+          </a:xfrm>
+          <a:prstGeom prst="rect">
+            <a:avLst/>
+          </a:prstGeom>
+          <a:noFill/>
+        </p:spPr>
+        <p:txBody>
+          <a:bodyPr wrap="square">
+            <a:spAutoFit/>
+          </a:bodyPr>
+          <a:lstStyle/>
+          <a:p>
+            <a:pPr algn="ctr"/>
+            <a:r>
+              <a:rPr sz="1500" b="1" i="0">
+                <a:solidFill>
+                  <a:srgbClr val="FFFFFF"/>
+                </a:solidFill>
+                <a:latin typeface="Calibri"/>
+              </a:rPr>
+              <a:t>01</a:t>
+            </a:r>
+          </a:p>
+        </p:txBody>
+      </p:sp>
+      <p:sp>
+        <p:nvSpPr>
+          <p:cNvPr id="10" name="TextBox 9"/>
+          <p:cNvSpPr txBox="1"/>
+          <p:nvPr/>
+        </p:nvSpPr>
+        <p:spPr>
+          <a:xfrm>
+            <a:off x="576072" y="3429000"/>
+            <a:ext cx="3108960" cy="502920"/>
+          </a:xfrm>
+          <a:prstGeom prst="rect">
+            <a:avLst/>
+          </a:prstGeom>
+          <a:noFill/>
+        </p:spPr>
+        <p:txBody>
+          <a:bodyPr wrap="square">
+            <a:spAutoFit/>
+          </a:bodyPr>
+          <a:lstStyle/>
+          <a:p>
+            <a:pPr algn="l"/>
+            <a:r>
+              <a:rPr sz="2200" b="1" i="0">
+                <a:solidFill>
+                  <a:srgbClr val="0A1E35"/>
+                </a:solidFill>
+                <a:latin typeface="Calibri"/>
+              </a:rPr>
+              <a:t>Registra</a:t>
+            </a:r>
+          </a:p>
+        </p:txBody>
+      </p:sp>
+      <p:sp>
+        <p:nvSpPr>
+          <p:cNvPr id="11" name="TextBox 10"/>
+          <p:cNvSpPr txBox="1"/>
+          <p:nvPr/>
+        </p:nvSpPr>
+        <p:spPr>
+          <a:xfrm>
+            <a:off x="576072" y="4023360"/>
+            <a:ext cx="3108960" cy="1371600"/>
+          </a:xfrm>
+          <a:prstGeom prst="rect">
+            <a:avLst/>
+          </a:prstGeom>
+          <a:noFill/>
+        </p:spPr>
+        <p:txBody>
+          <a:bodyPr wrap="square">
+            <a:spAutoFit/>
+          </a:bodyPr>
+          <a:lstStyle/>
+          <a:p>
+            <a:pPr algn="l"/>
+            <a:r>
+              <a:rPr sz="1400" b="0" i="0">
+                <a:solidFill>
+                  <a:srgbClr val="3D6080"/>
+                </a:solidFill>
+                <a:latin typeface="Calibri"/>
+              </a:rPr>
+              <a:t>Marca, modelo, km, foto.
+Todo en un solo lugar.</a:t>
+            </a:r>
+          </a:p>
+        </p:txBody>
+      </p:sp>
+      <p:sp>
+        <p:nvSpPr>
+          <p:cNvPr id="12" name="Rectangle 11"/>
+          <p:cNvSpPr/>
+          <p:nvPr/>
+        </p:nvSpPr>
+        <p:spPr>
+          <a:xfrm>
+            <a:off x="4187952" y="2468880"/>
+            <a:ext cx="3429000" cy="3337560"/>
+          </a:xfrm>
+          <a:prstGeom prst="rect">
+            <a:avLst/>
+          </a:prstGeom>
+          <a:solidFill>
+            <a:srgbClr val="F5FAFF"/>
+          </a:solidFill>
+          <a:ln w="12700">
+            <a:solidFill>
+              <a:srgbClr val="C5DDEF"/>
+            </a:solidFill>
+          </a:ln>
+        </p:spPr>
+        <p:style>
+          <a:lnRef idx="1">
+            <a:schemeClr val="accent1"/>
+          </a:lnRef>
+          <a:fillRef idx="3">
+            <a:schemeClr val="accent1"/>
+          </a:fillRef>
+          <a:effectRef idx="2">
+            <a:schemeClr val="accent1"/>
+          </a:effectRef>
+          <a:fontRef idx="minor">
+            <a:schemeClr val="lt1"/>
+          </a:fontRef>
+        </p:style>
+        <p:txBody>
+          <a:bodyPr rtlCol="0" anchor="ctr"/>
+          <a:lstStyle/>
+          <a:p>
+            <a:pPr algn="ctr"/>
+          </a:p>
+        </p:txBody>
+      </p:sp>
+      <p:sp>
+        <p:nvSpPr>
+          <p:cNvPr id="13" name="Rectangle 12"/>
+          <p:cNvSpPr/>
+          <p:nvPr/>
+        </p:nvSpPr>
+        <p:spPr>
+          <a:xfrm>
+            <a:off x="4187952" y="2468880"/>
+            <a:ext cx="3429000" cy="128016"/>
           </a:xfrm>
           <a:prstGeom prst="rect">
             <a:avLst/>
@@ -4048,322 +4718,16 @@
       </p:sp>
       <p:sp>
         <p:nvSpPr>
-          <p:cNvPr id="3" name="TextBox 2"/>
-          <p:cNvSpPr txBox="1"/>
-          <p:nvPr/>
-        </p:nvSpPr>
-        <p:spPr>
-          <a:xfrm>
-            <a:off x="457200" y="320040"/>
-            <a:ext cx="8229600" cy="411480"/>
-          </a:xfrm>
-          <a:prstGeom prst="rect">
-            <a:avLst/>
-          </a:prstGeom>
-          <a:noFill/>
-        </p:spPr>
-        <p:txBody>
-          <a:bodyPr wrap="square">
-            <a:spAutoFit/>
-          </a:bodyPr>
-          <a:lstStyle/>
-          <a:p>
-            <a:pPr algn="l"/>
-            <a:r>
-              <a:rPr sz="1200" b="1" i="0">
-                <a:solidFill>
-                  <a:srgbClr val="F5A623"/>
-                </a:solidFill>
-                <a:latin typeface="Calibri"/>
-              </a:rPr>
-              <a:t>LA SOLUCIÓN</a:t>
-            </a:r>
-          </a:p>
-        </p:txBody>
-      </p:sp>
-      <p:sp>
-        <p:nvSpPr>
-          <p:cNvPr id="4" name="TextBox 3"/>
-          <p:cNvSpPr txBox="1"/>
-          <p:nvPr/>
-        </p:nvSpPr>
-        <p:spPr>
-          <a:xfrm>
-            <a:off x="457200" y="822960"/>
-            <a:ext cx="8686800" cy="1463040"/>
-          </a:xfrm>
-          <a:prstGeom prst="rect">
-            <a:avLst/>
-          </a:prstGeom>
-          <a:noFill/>
-        </p:spPr>
-        <p:txBody>
-          <a:bodyPr wrap="square">
-            <a:spAutoFit/>
-          </a:bodyPr>
-          <a:lstStyle/>
-          <a:p>
-            <a:pPr algn="l"/>
-            <a:r>
-              <a:rPr sz="3800" b="1" i="0">
-                <a:solidFill>
-                  <a:srgbClr val="1C1C2E"/>
-                </a:solidFill>
-                <a:latin typeface="Calibri"/>
-              </a:rPr>
-              <a:t>Una app web mobile-first para llevar
-el control total de tus vehículos.</a:t>
-            </a:r>
-          </a:p>
-        </p:txBody>
-      </p:sp>
-      <p:sp>
-        <p:nvSpPr>
-          <p:cNvPr id="5" name="Rectangle 4"/>
+          <p:cNvPr id="14" name="Oval 13"/>
           <p:cNvSpPr/>
           <p:nvPr/>
         </p:nvSpPr>
         <p:spPr>
           <a:xfrm>
-            <a:off x="457200" y="2560320"/>
-            <a:ext cx="3566160" cy="3200400"/>
-          </a:xfrm>
-          <a:prstGeom prst="rect">
-            <a:avLst/>
-          </a:prstGeom>
-          <a:solidFill>
-            <a:srgbClr val="FFFFFF"/>
-          </a:solidFill>
-          <a:ln>
-            <a:noFill/>
-          </a:ln>
-        </p:spPr>
-        <p:style>
-          <a:lnRef idx="1">
-            <a:schemeClr val="accent1"/>
-          </a:lnRef>
-          <a:fillRef idx="3">
-            <a:schemeClr val="accent1"/>
-          </a:fillRef>
-          <a:effectRef idx="2">
-            <a:schemeClr val="accent1"/>
-          </a:effectRef>
-          <a:fontRef idx="minor">
-            <a:schemeClr val="lt1"/>
-          </a:fontRef>
-        </p:style>
-        <p:txBody>
-          <a:bodyPr rtlCol="0" anchor="ctr"/>
-          <a:lstStyle/>
-          <a:p>
-            <a:pPr algn="ctr"/>
-          </a:p>
-        </p:txBody>
-      </p:sp>
-      <p:sp>
-        <p:nvSpPr>
-          <p:cNvPr id="6" name="Rectangle 5"/>
-          <p:cNvSpPr/>
-          <p:nvPr/>
-        </p:nvSpPr>
-        <p:spPr>
-          <a:xfrm>
-            <a:off x="457200" y="2560320"/>
-            <a:ext cx="3566160" cy="109728"/>
-          </a:xfrm>
-          <a:prstGeom prst="rect">
-            <a:avLst/>
-          </a:prstGeom>
-          <a:solidFill>
-            <a:srgbClr val="27AE60"/>
-          </a:solidFill>
-          <a:ln>
-            <a:noFill/>
-          </a:ln>
-        </p:spPr>
-        <p:style>
-          <a:lnRef idx="1">
-            <a:schemeClr val="accent1"/>
-          </a:lnRef>
-          <a:fillRef idx="3">
-            <a:schemeClr val="accent1"/>
-          </a:fillRef>
-          <a:effectRef idx="2">
-            <a:schemeClr val="accent1"/>
-          </a:effectRef>
-          <a:fontRef idx="minor">
-            <a:schemeClr val="lt1"/>
-          </a:fontRef>
-        </p:style>
-        <p:txBody>
-          <a:bodyPr rtlCol="0" anchor="ctr"/>
-          <a:lstStyle/>
-          <a:p>
-            <a:pPr algn="ctr"/>
-          </a:p>
-        </p:txBody>
-      </p:sp>
-      <p:sp>
-        <p:nvSpPr>
-          <p:cNvPr id="7" name="TextBox 6"/>
-          <p:cNvSpPr txBox="1"/>
-          <p:nvPr/>
-        </p:nvSpPr>
-        <p:spPr>
-          <a:xfrm>
-            <a:off x="594360" y="2788920"/>
-            <a:ext cx="914400" cy="640080"/>
-          </a:xfrm>
-          <a:prstGeom prst="rect">
-            <a:avLst/>
-          </a:prstGeom>
-          <a:noFill/>
-        </p:spPr>
-        <p:txBody>
-          <a:bodyPr wrap="square">
-            <a:spAutoFit/>
-          </a:bodyPr>
-          <a:lstStyle/>
-          <a:p>
-            <a:pPr algn="l"/>
-            <a:r>
-              <a:rPr sz="3000" b="0" i="0">
-                <a:solidFill>
-                  <a:srgbClr val="1C1C2E"/>
-                </a:solidFill>
-                <a:latin typeface="Calibri"/>
-              </a:rPr>
-              <a:t>📋</a:t>
-            </a:r>
-          </a:p>
-        </p:txBody>
-      </p:sp>
-      <p:sp>
-        <p:nvSpPr>
-          <p:cNvPr id="8" name="TextBox 7"/>
-          <p:cNvSpPr txBox="1"/>
-          <p:nvPr/>
-        </p:nvSpPr>
-        <p:spPr>
-          <a:xfrm>
-            <a:off x="594360" y="3520439"/>
-            <a:ext cx="3291840" cy="502920"/>
-          </a:xfrm>
-          <a:prstGeom prst="rect">
-            <a:avLst/>
-          </a:prstGeom>
-          <a:noFill/>
-        </p:spPr>
-        <p:txBody>
-          <a:bodyPr wrap="square">
-            <a:spAutoFit/>
-          </a:bodyPr>
-          <a:lstStyle/>
-          <a:p>
-            <a:pPr algn="l"/>
-            <a:r>
-              <a:rPr sz="2200" b="1" i="0">
-                <a:solidFill>
-                  <a:srgbClr val="1C1C2E"/>
-                </a:solidFill>
-                <a:latin typeface="Calibri"/>
-              </a:rPr>
-              <a:t>Registra</a:t>
-            </a:r>
-          </a:p>
-        </p:txBody>
-      </p:sp>
-      <p:sp>
-        <p:nvSpPr>
-          <p:cNvPr id="9" name="TextBox 8"/>
-          <p:cNvSpPr txBox="1"/>
-          <p:nvPr/>
-        </p:nvSpPr>
-        <p:spPr>
-          <a:xfrm>
-            <a:off x="594360" y="4114800"/>
-            <a:ext cx="3291840" cy="1280160"/>
-          </a:xfrm>
-          <a:prstGeom prst="rect">
-            <a:avLst/>
-          </a:prstGeom>
-          <a:noFill/>
-        </p:spPr>
-        <p:txBody>
-          <a:bodyPr wrap="square">
-            <a:spAutoFit/>
-          </a:bodyPr>
-          <a:lstStyle/>
-          <a:p>
-            <a:pPr algn="l"/>
-            <a:r>
-              <a:rPr sz="1500" b="0" i="0">
-                <a:solidFill>
-                  <a:srgbClr val="4A5568"/>
-                </a:solidFill>
-                <a:latin typeface="Calibri"/>
-              </a:rPr>
-              <a:t>Marca, modelo, km, foto.
-Todo en un lugar.</a:t>
-            </a:r>
-          </a:p>
-        </p:txBody>
-      </p:sp>
-      <p:sp>
-        <p:nvSpPr>
-          <p:cNvPr id="10" name="Rectangle 9"/>
-          <p:cNvSpPr/>
-          <p:nvPr/>
-        </p:nvSpPr>
-        <p:spPr>
-          <a:xfrm>
-            <a:off x="4315968" y="2560320"/>
-            <a:ext cx="3566160" cy="3200400"/>
-          </a:xfrm>
-          <a:prstGeom prst="rect">
-            <a:avLst/>
-          </a:prstGeom>
-          <a:solidFill>
-            <a:srgbClr val="FFFFFF"/>
-          </a:solidFill>
-          <a:ln>
-            <a:noFill/>
-          </a:ln>
-        </p:spPr>
-        <p:style>
-          <a:lnRef idx="1">
-            <a:schemeClr val="accent1"/>
-          </a:lnRef>
-          <a:fillRef idx="3">
-            <a:schemeClr val="accent1"/>
-          </a:fillRef>
-          <a:effectRef idx="2">
-            <a:schemeClr val="accent1"/>
-          </a:effectRef>
-          <a:fontRef idx="minor">
-            <a:schemeClr val="lt1"/>
-          </a:fontRef>
-        </p:style>
-        <p:txBody>
-          <a:bodyPr rtlCol="0" anchor="ctr"/>
-          <a:lstStyle/>
-          <a:p>
-            <a:pPr algn="ctr"/>
-          </a:p>
-        </p:txBody>
-      </p:sp>
-      <p:sp>
-        <p:nvSpPr>
-          <p:cNvPr id="11" name="Rectangle 10"/>
-          <p:cNvSpPr/>
-          <p:nvPr/>
-        </p:nvSpPr>
-        <p:spPr>
-          <a:xfrm>
-            <a:off x="4315968" y="2560320"/>
-            <a:ext cx="3566160" cy="109728"/>
-          </a:xfrm>
-          <a:prstGeom prst="rect">
+            <a:off x="4389120" y="2761488"/>
+            <a:ext cx="502920" cy="502920"/>
+          </a:xfrm>
+          <a:prstGeom prst="ellipse">
             <a:avLst/>
           </a:prstGeom>
           <a:solidFill>
@@ -4397,14 +4761,14 @@
       </p:sp>
       <p:sp>
         <p:nvSpPr>
-          <p:cNvPr id="12" name="TextBox 11"/>
+          <p:cNvPr id="15" name="TextBox 14"/>
           <p:cNvSpPr txBox="1"/>
           <p:nvPr/>
         </p:nvSpPr>
         <p:spPr>
           <a:xfrm>
-            <a:off x="4453128" y="2788920"/>
-            <a:ext cx="914400" cy="640080"/>
+            <a:off x="4389120" y="2761488"/>
+            <a:ext cx="502920" cy="502920"/>
           </a:xfrm>
           <a:prstGeom prst="rect">
             <a:avLst/>
@@ -4417,29 +4781,29 @@
           </a:bodyPr>
           <a:lstStyle/>
           <a:p>
-            <a:pPr algn="l"/>
-            <a:r>
-              <a:rPr sz="3000" b="0" i="0">
+            <a:pPr algn="ctr"/>
+            <a:r>
+              <a:rPr sz="1500" b="1" i="0">
                 <a:solidFill>
-                  <a:srgbClr val="1C1C2E"/>
+                  <a:srgbClr val="FFFFFF"/>
                 </a:solidFill>
                 <a:latin typeface="Calibri"/>
               </a:rPr>
-              <a:t>📊</a:t>
-            </a:r>
-          </a:p>
-        </p:txBody>
-      </p:sp>
-      <p:sp>
-        <p:nvSpPr>
-          <p:cNvPr id="13" name="TextBox 12"/>
+              <a:t>02</a:t>
+            </a:r>
+          </a:p>
+        </p:txBody>
+      </p:sp>
+      <p:sp>
+        <p:nvSpPr>
+          <p:cNvPr id="16" name="TextBox 15"/>
           <p:cNvSpPr txBox="1"/>
           <p:nvPr/>
         </p:nvSpPr>
         <p:spPr>
           <a:xfrm>
-            <a:off x="4453128" y="3520439"/>
-            <a:ext cx="3291840" cy="502920"/>
+            <a:off x="4352544" y="3429000"/>
+            <a:ext cx="3108960" cy="502920"/>
           </a:xfrm>
           <a:prstGeom prst="rect">
             <a:avLst/>
@@ -4456,7 +4820,7 @@
             <a:r>
               <a:rPr sz="2200" b="1" i="0">
                 <a:solidFill>
-                  <a:srgbClr val="1C1C2E"/>
+                  <a:srgbClr val="0A1E35"/>
                 </a:solidFill>
                 <a:latin typeface="Calibri"/>
               </a:rPr>
@@ -4467,14 +4831,14 @@
       </p:sp>
       <p:sp>
         <p:nvSpPr>
-          <p:cNvPr id="14" name="TextBox 13"/>
+          <p:cNvPr id="17" name="TextBox 16"/>
           <p:cNvSpPr txBox="1"/>
           <p:nvPr/>
         </p:nvSpPr>
         <p:spPr>
           <a:xfrm>
-            <a:off x="4453128" y="4114800"/>
-            <a:ext cx="3291840" cy="1280160"/>
+            <a:off x="4352544" y="4023360"/>
+            <a:ext cx="3108960" cy="1371600"/>
           </a:xfrm>
           <a:prstGeom prst="rect">
             <a:avLst/>
@@ -4489,9 +4853,9 @@
           <a:p>
             <a:pPr algn="l"/>
             <a:r>
-              <a:rPr sz="1500" b="0" i="0">
+              <a:rPr sz="1400" b="0" i="0">
                 <a:solidFill>
-                  <a:srgbClr val="4A5568"/>
+                  <a:srgbClr val="3D6080"/>
                 </a:solidFill>
                 <a:latin typeface="Calibri"/>
               </a:rPr>
@@ -4503,23 +4867,25 @@
       </p:sp>
       <p:sp>
         <p:nvSpPr>
-          <p:cNvPr id="15" name="Rectangle 14"/>
+          <p:cNvPr id="18" name="Rectangle 17"/>
           <p:cNvSpPr/>
           <p:nvPr/>
         </p:nvSpPr>
         <p:spPr>
           <a:xfrm>
-            <a:off x="8174736" y="2560320"/>
-            <a:ext cx="3566160" cy="3200400"/>
+            <a:off x="7964424" y="2468880"/>
+            <a:ext cx="3429000" cy="3337560"/>
           </a:xfrm>
           <a:prstGeom prst="rect">
             <a:avLst/>
           </a:prstGeom>
           <a:solidFill>
-            <a:srgbClr val="FFFFFF"/>
+            <a:srgbClr val="F5FAFF"/>
           </a:solidFill>
-          <a:ln>
-            <a:noFill/>
+          <a:ln w="12700">
+            <a:solidFill>
+              <a:srgbClr val="C5DDEF"/>
+            </a:solidFill>
           </a:ln>
         </p:spPr>
         <p:style>
@@ -4546,20 +4912,20 @@
       </p:sp>
       <p:sp>
         <p:nvSpPr>
-          <p:cNvPr id="16" name="Rectangle 15"/>
+          <p:cNvPr id="19" name="Rectangle 18"/>
           <p:cNvSpPr/>
           <p:nvPr/>
         </p:nvSpPr>
         <p:spPr>
           <a:xfrm>
-            <a:off x="8174736" y="2560320"/>
-            <a:ext cx="3566160" cy="109728"/>
+            <a:off x="7964424" y="2468880"/>
+            <a:ext cx="3429000" cy="128016"/>
           </a:xfrm>
           <a:prstGeom prst="rect">
             <a:avLst/>
           </a:prstGeom>
           <a:solidFill>
-            <a:srgbClr val="E74C3C"/>
+            <a:srgbClr val="E8453C"/>
           </a:solidFill>
           <a:ln>
             <a:noFill/>
@@ -4589,14 +4955,57 @@
       </p:sp>
       <p:sp>
         <p:nvSpPr>
-          <p:cNvPr id="17" name="TextBox 16"/>
+          <p:cNvPr id="20" name="Oval 19"/>
+          <p:cNvSpPr/>
+          <p:nvPr/>
+        </p:nvSpPr>
+        <p:spPr>
+          <a:xfrm>
+            <a:off x="8165592" y="2761488"/>
+            <a:ext cx="502920" cy="502920"/>
+          </a:xfrm>
+          <a:prstGeom prst="ellipse">
+            <a:avLst/>
+          </a:prstGeom>
+          <a:solidFill>
+            <a:srgbClr val="E8453C"/>
+          </a:solidFill>
+          <a:ln>
+            <a:noFill/>
+          </a:ln>
+        </p:spPr>
+        <p:style>
+          <a:lnRef idx="1">
+            <a:schemeClr val="accent1"/>
+          </a:lnRef>
+          <a:fillRef idx="3">
+            <a:schemeClr val="accent1"/>
+          </a:fillRef>
+          <a:effectRef idx="2">
+            <a:schemeClr val="accent1"/>
+          </a:effectRef>
+          <a:fontRef idx="minor">
+            <a:schemeClr val="lt1"/>
+          </a:fontRef>
+        </p:style>
+        <p:txBody>
+          <a:bodyPr rtlCol="0" anchor="ctr"/>
+          <a:lstStyle/>
+          <a:p>
+            <a:pPr algn="ctr"/>
+          </a:p>
+        </p:txBody>
+      </p:sp>
+      <p:sp>
+        <p:nvSpPr>
+          <p:cNvPr id="21" name="TextBox 20"/>
           <p:cNvSpPr txBox="1"/>
           <p:nvPr/>
         </p:nvSpPr>
         <p:spPr>
           <a:xfrm>
-            <a:off x="8311896" y="2788920"/>
-            <a:ext cx="914400" cy="640080"/>
+            <a:off x="8165592" y="2761488"/>
+            <a:ext cx="502920" cy="502920"/>
           </a:xfrm>
           <a:prstGeom prst="rect">
             <a:avLst/>
@@ -4609,29 +5018,29 @@
           </a:bodyPr>
           <a:lstStyle/>
           <a:p>
-            <a:pPr algn="l"/>
-            <a:r>
-              <a:rPr sz="3000" b="0" i="0">
+            <a:pPr algn="ctr"/>
+            <a:r>
+              <a:rPr sz="1500" b="1" i="0">
                 <a:solidFill>
-                  <a:srgbClr val="1C1C2E"/>
+                  <a:srgbClr val="FFFFFF"/>
                 </a:solidFill>
                 <a:latin typeface="Calibri"/>
               </a:rPr>
-              <a:t>🔔</a:t>
-            </a:r>
-          </a:p>
-        </p:txBody>
-      </p:sp>
-      <p:sp>
-        <p:nvSpPr>
-          <p:cNvPr id="18" name="TextBox 17"/>
+              <a:t>03</a:t>
+            </a:r>
+          </a:p>
+        </p:txBody>
+      </p:sp>
+      <p:sp>
+        <p:nvSpPr>
+          <p:cNvPr id="22" name="TextBox 21"/>
           <p:cNvSpPr txBox="1"/>
           <p:nvPr/>
         </p:nvSpPr>
         <p:spPr>
           <a:xfrm>
-            <a:off x="8311896" y="3520439"/>
-            <a:ext cx="3291840" cy="502920"/>
+            <a:off x="8129016" y="3429000"/>
+            <a:ext cx="3108960" cy="502920"/>
           </a:xfrm>
           <a:prstGeom prst="rect">
             <a:avLst/>
@@ -4648,7 +5057,7 @@
             <a:r>
               <a:rPr sz="2200" b="1" i="0">
                 <a:solidFill>
-                  <a:srgbClr val="1C1C2E"/>
+                  <a:srgbClr val="0A1E35"/>
                 </a:solidFill>
                 <a:latin typeface="Calibri"/>
               </a:rPr>
@@ -4659,14 +5068,14 @@
       </p:sp>
       <p:sp>
         <p:nvSpPr>
-          <p:cNvPr id="19" name="TextBox 18"/>
+          <p:cNvPr id="23" name="TextBox 22"/>
           <p:cNvSpPr txBox="1"/>
           <p:nvPr/>
         </p:nvSpPr>
         <p:spPr>
           <a:xfrm>
-            <a:off x="8311896" y="4114800"/>
-            <a:ext cx="3291840" cy="1280160"/>
+            <a:off x="8129016" y="4023360"/>
+            <a:ext cx="3108960" cy="1371600"/>
           </a:xfrm>
           <a:prstGeom prst="rect">
             <a:avLst/>
@@ -4681,9 +5090,9 @@
           <a:p>
             <a:pPr algn="l"/>
             <a:r>
-              <a:rPr sz="1500" b="0" i="0">
+              <a:rPr sz="1400" b="0" i="0">
                 <a:solidFill>
-                  <a:srgbClr val="4A5568"/>
+                  <a:srgbClr val="3D6080"/>
                 </a:solidFill>
                 <a:latin typeface="Calibri"/>
               </a:rPr>
@@ -4707,7 +5116,7 @@
     <p:bg>
       <p:bgPr>
         <a:solidFill>
-          <a:srgbClr val="F4F6F9"/>
+          <a:srgbClr val="FFFFFF"/>
         </a:solidFill>
         <a:effectLst/>
       </p:bgPr>
@@ -4728,7 +5137,445 @@
         <p:spPr>
           <a:xfrm>
             <a:off x="0" y="0"/>
+            <a:ext cx="12188952" cy="73152"/>
+          </a:xfrm>
+          <a:prstGeom prst="rect">
+            <a:avLst/>
+          </a:prstGeom>
+          <a:solidFill>
+            <a:srgbClr val="016CB0"/>
+          </a:solidFill>
+          <a:ln>
+            <a:noFill/>
+          </a:ln>
+        </p:spPr>
+        <p:style>
+          <a:lnRef idx="1">
+            <a:schemeClr val="accent1"/>
+          </a:lnRef>
+          <a:fillRef idx="3">
+            <a:schemeClr val="accent1"/>
+          </a:fillRef>
+          <a:effectRef idx="2">
+            <a:schemeClr val="accent1"/>
+          </a:effectRef>
+          <a:fontRef idx="minor">
+            <a:schemeClr val="lt1"/>
+          </a:fontRef>
+        </p:style>
+        <p:txBody>
+          <a:bodyPr rtlCol="0" anchor="ctr"/>
+          <a:lstStyle/>
+          <a:p>
+            <a:pPr algn="ctr"/>
+          </a:p>
+        </p:txBody>
+      </p:sp>
+      <p:sp>
+        <p:nvSpPr>
+          <p:cNvPr id="3" name="Rectangle 2"/>
+          <p:cNvSpPr/>
+          <p:nvPr/>
+        </p:nvSpPr>
+        <p:spPr>
+          <a:xfrm>
+            <a:off x="0" y="0"/>
             <a:ext cx="164592" cy="6858000"/>
+          </a:xfrm>
+          <a:prstGeom prst="rect">
+            <a:avLst/>
+          </a:prstGeom>
+          <a:solidFill>
+            <a:srgbClr val="016CB0"/>
+          </a:solidFill>
+          <a:ln>
+            <a:noFill/>
+          </a:ln>
+        </p:spPr>
+        <p:style>
+          <a:lnRef idx="1">
+            <a:schemeClr val="accent1"/>
+          </a:lnRef>
+          <a:fillRef idx="3">
+            <a:schemeClr val="accent1"/>
+          </a:fillRef>
+          <a:effectRef idx="2">
+            <a:schemeClr val="accent1"/>
+          </a:effectRef>
+          <a:fontRef idx="minor">
+            <a:schemeClr val="lt1"/>
+          </a:fontRef>
+        </p:style>
+        <p:txBody>
+          <a:bodyPr rtlCol="0" anchor="ctr"/>
+          <a:lstStyle/>
+          <a:p>
+            <a:pPr algn="ctr"/>
+          </a:p>
+        </p:txBody>
+      </p:sp>
+      <p:sp>
+        <p:nvSpPr>
+          <p:cNvPr id="4" name="TextBox 3"/>
+          <p:cNvSpPr txBox="1"/>
+          <p:nvPr/>
+        </p:nvSpPr>
+        <p:spPr>
+          <a:xfrm>
+            <a:off x="411480" y="228600"/>
+            <a:ext cx="8229600" cy="365760"/>
+          </a:xfrm>
+          <a:prstGeom prst="rect">
+            <a:avLst/>
+          </a:prstGeom>
+          <a:noFill/>
+        </p:spPr>
+        <p:txBody>
+          <a:bodyPr wrap="square">
+            <a:spAutoFit/>
+          </a:bodyPr>
+          <a:lstStyle/>
+          <a:p>
+            <a:pPr algn="l"/>
+            <a:r>
+              <a:rPr sz="1100" b="1" i="0">
+                <a:solidFill>
+                  <a:srgbClr val="016CB0"/>
+                </a:solidFill>
+                <a:latin typeface="Calibri"/>
+              </a:rPr>
+              <a:t>ASÍ FUNCIONA</a:t>
+            </a:r>
+          </a:p>
+        </p:txBody>
+      </p:sp>
+      <p:sp>
+        <p:nvSpPr>
+          <p:cNvPr id="5" name="TextBox 4"/>
+          <p:cNvSpPr txBox="1"/>
+          <p:nvPr/>
+        </p:nvSpPr>
+        <p:spPr>
+          <a:xfrm>
+            <a:off x="411480" y="685800"/>
+            <a:ext cx="8686800" cy="822960"/>
+          </a:xfrm>
+          <a:prstGeom prst="rect">
+            <a:avLst/>
+          </a:prstGeom>
+          <a:noFill/>
+        </p:spPr>
+        <p:txBody>
+          <a:bodyPr wrap="square">
+            <a:spAutoFit/>
+          </a:bodyPr>
+          <a:lstStyle/>
+          <a:p>
+            <a:pPr algn="l"/>
+            <a:r>
+              <a:rPr sz="4200" b="1" i="0">
+                <a:solidFill>
+                  <a:srgbClr val="0A1E35"/>
+                </a:solidFill>
+                <a:latin typeface="Calibri"/>
+              </a:rPr>
+              <a:t>El semáforo de tu coche</a:t>
+            </a:r>
+          </a:p>
+        </p:txBody>
+      </p:sp>
+      <p:sp>
+        <p:nvSpPr>
+          <p:cNvPr id="6" name="TextBox 5"/>
+          <p:cNvSpPr txBox="1"/>
+          <p:nvPr/>
+        </p:nvSpPr>
+        <p:spPr>
+          <a:xfrm>
+            <a:off x="411480" y="1600200"/>
+            <a:ext cx="8686800" cy="457200"/>
+          </a:xfrm>
+          <a:prstGeom prst="rect">
+            <a:avLst/>
+          </a:prstGeom>
+          <a:noFill/>
+        </p:spPr>
+        <p:txBody>
+          <a:bodyPr wrap="square">
+            <a:spAutoFit/>
+          </a:bodyPr>
+          <a:lstStyle/>
+          <a:p>
+            <a:pPr algn="l"/>
+            <a:r>
+              <a:rPr sz="1600" b="0" i="0">
+                <a:solidFill>
+                  <a:srgbClr val="3D6080"/>
+                </a:solidFill>
+                <a:latin typeface="Calibri"/>
+              </a:rPr>
+              <a:t>Un vistazo y sabes exactamente qué necesita atención.</a:t>
+            </a:r>
+          </a:p>
+        </p:txBody>
+      </p:sp>
+      <p:sp>
+        <p:nvSpPr>
+          <p:cNvPr id="7" name="Rectangle 6"/>
+          <p:cNvSpPr/>
+          <p:nvPr/>
+        </p:nvSpPr>
+        <p:spPr>
+          <a:xfrm>
+            <a:off x="411480" y="2377440"/>
+            <a:ext cx="3429000" cy="3520440"/>
+          </a:xfrm>
+          <a:prstGeom prst="rect">
+            <a:avLst/>
+          </a:prstGeom>
+          <a:solidFill>
+            <a:srgbClr val="FFFFFF"/>
+          </a:solidFill>
+          <a:ln w="31750">
+            <a:solidFill>
+              <a:srgbClr val="1DB954"/>
+            </a:solidFill>
+          </a:ln>
+        </p:spPr>
+        <p:style>
+          <a:lnRef idx="1">
+            <a:schemeClr val="accent1"/>
+          </a:lnRef>
+          <a:fillRef idx="3">
+            <a:schemeClr val="accent1"/>
+          </a:fillRef>
+          <a:effectRef idx="2">
+            <a:schemeClr val="accent1"/>
+          </a:effectRef>
+          <a:fontRef idx="minor">
+            <a:schemeClr val="lt1"/>
+          </a:fontRef>
+        </p:style>
+        <p:txBody>
+          <a:bodyPr rtlCol="0" anchor="ctr"/>
+          <a:lstStyle/>
+          <a:p>
+            <a:pPr algn="ctr"/>
+          </a:p>
+        </p:txBody>
+      </p:sp>
+      <p:sp>
+        <p:nvSpPr>
+          <p:cNvPr id="8" name="Rectangle 7"/>
+          <p:cNvSpPr/>
+          <p:nvPr/>
+        </p:nvSpPr>
+        <p:spPr>
+          <a:xfrm>
+            <a:off x="411480" y="2377440"/>
+            <a:ext cx="3429000" cy="128016"/>
+          </a:xfrm>
+          <a:prstGeom prst="rect">
+            <a:avLst/>
+          </a:prstGeom>
+          <a:solidFill>
+            <a:srgbClr val="1DB954"/>
+          </a:solidFill>
+          <a:ln>
+            <a:noFill/>
+          </a:ln>
+        </p:spPr>
+        <p:style>
+          <a:lnRef idx="1">
+            <a:schemeClr val="accent1"/>
+          </a:lnRef>
+          <a:fillRef idx="3">
+            <a:schemeClr val="accent1"/>
+          </a:fillRef>
+          <a:effectRef idx="2">
+            <a:schemeClr val="accent1"/>
+          </a:effectRef>
+          <a:fontRef idx="minor">
+            <a:schemeClr val="lt1"/>
+          </a:fontRef>
+        </p:style>
+        <p:txBody>
+          <a:bodyPr rtlCol="0" anchor="ctr"/>
+          <a:lstStyle/>
+          <a:p>
+            <a:pPr algn="ctr"/>
+          </a:p>
+        </p:txBody>
+      </p:sp>
+      <p:sp>
+        <p:nvSpPr>
+          <p:cNvPr id="9" name="Oval 8"/>
+          <p:cNvSpPr/>
+          <p:nvPr/>
+        </p:nvSpPr>
+        <p:spPr>
+          <a:xfrm>
+            <a:off x="1577339" y="2743200"/>
+            <a:ext cx="1097280" cy="1097280"/>
+          </a:xfrm>
+          <a:prstGeom prst="ellipse">
+            <a:avLst/>
+          </a:prstGeom>
+          <a:solidFill>
+            <a:srgbClr val="1DB954"/>
+          </a:solidFill>
+          <a:ln>
+            <a:noFill/>
+          </a:ln>
+        </p:spPr>
+        <p:style>
+          <a:lnRef idx="1">
+            <a:schemeClr val="accent1"/>
+          </a:lnRef>
+          <a:fillRef idx="3">
+            <a:schemeClr val="accent1"/>
+          </a:fillRef>
+          <a:effectRef idx="2">
+            <a:schemeClr val="accent1"/>
+          </a:effectRef>
+          <a:fontRef idx="minor">
+            <a:schemeClr val="lt1"/>
+          </a:fontRef>
+        </p:style>
+        <p:txBody>
+          <a:bodyPr rtlCol="0" anchor="ctr"/>
+          <a:lstStyle/>
+          <a:p>
+            <a:pPr algn="ctr"/>
+          </a:p>
+        </p:txBody>
+      </p:sp>
+      <p:sp>
+        <p:nvSpPr>
+          <p:cNvPr id="10" name="TextBox 9"/>
+          <p:cNvSpPr txBox="1"/>
+          <p:nvPr/>
+        </p:nvSpPr>
+        <p:spPr>
+          <a:xfrm>
+            <a:off x="576072" y="4005072"/>
+            <a:ext cx="3108960" cy="502920"/>
+          </a:xfrm>
+          <a:prstGeom prst="rect">
+            <a:avLst/>
+          </a:prstGeom>
+          <a:noFill/>
+        </p:spPr>
+        <p:txBody>
+          <a:bodyPr wrap="square">
+            <a:spAutoFit/>
+          </a:bodyPr>
+          <a:lstStyle/>
+          <a:p>
+            <a:pPr algn="l"/>
+            <a:r>
+              <a:rPr sz="2000" b="1" i="0">
+                <a:solidFill>
+                  <a:srgbClr val="0A1E35"/>
+                </a:solidFill>
+                <a:latin typeface="Calibri"/>
+              </a:rPr>
+              <a:t>Todo en orden</a:t>
+            </a:r>
+          </a:p>
+        </p:txBody>
+      </p:sp>
+      <p:sp>
+        <p:nvSpPr>
+          <p:cNvPr id="11" name="TextBox 10"/>
+          <p:cNvSpPr txBox="1"/>
+          <p:nvPr/>
+        </p:nvSpPr>
+        <p:spPr>
+          <a:xfrm>
+            <a:off x="576072" y="4553712"/>
+            <a:ext cx="3108960" cy="1005840"/>
+          </a:xfrm>
+          <a:prstGeom prst="rect">
+            <a:avLst/>
+          </a:prstGeom>
+          <a:noFill/>
+        </p:spPr>
+        <p:txBody>
+          <a:bodyPr wrap="square">
+            <a:spAutoFit/>
+          </a:bodyPr>
+          <a:lstStyle/>
+          <a:p>
+            <a:pPr algn="l"/>
+            <a:r>
+              <a:rPr sz="1400" b="0" i="0">
+                <a:solidFill>
+                  <a:srgbClr val="3D6080"/>
+                </a:solidFill>
+                <a:latin typeface="Calibri"/>
+              </a:rPr>
+              <a:t>Revisiones al día.
+Sin preocupaciones.</a:t>
+            </a:r>
+          </a:p>
+        </p:txBody>
+      </p:sp>
+      <p:sp>
+        <p:nvSpPr>
+          <p:cNvPr id="12" name="Rectangle 11"/>
+          <p:cNvSpPr/>
+          <p:nvPr/>
+        </p:nvSpPr>
+        <p:spPr>
+          <a:xfrm>
+            <a:off x="4187952" y="2377440"/>
+            <a:ext cx="3429000" cy="3520440"/>
+          </a:xfrm>
+          <a:prstGeom prst="rect">
+            <a:avLst/>
+          </a:prstGeom>
+          <a:solidFill>
+            <a:srgbClr val="FFFFFF"/>
+          </a:solidFill>
+          <a:ln w="31750">
+            <a:solidFill>
+              <a:srgbClr val="F5A623"/>
+            </a:solidFill>
+          </a:ln>
+        </p:spPr>
+        <p:style>
+          <a:lnRef idx="1">
+            <a:schemeClr val="accent1"/>
+          </a:lnRef>
+          <a:fillRef idx="3">
+            <a:schemeClr val="accent1"/>
+          </a:fillRef>
+          <a:effectRef idx="2">
+            <a:schemeClr val="accent1"/>
+          </a:effectRef>
+          <a:fontRef idx="minor">
+            <a:schemeClr val="lt1"/>
+          </a:fontRef>
+        </p:style>
+        <p:txBody>
+          <a:bodyPr rtlCol="0" anchor="ctr"/>
+          <a:lstStyle/>
+          <a:p>
+            <a:pPr algn="ctr"/>
+          </a:p>
+        </p:txBody>
+      </p:sp>
+      <p:sp>
+        <p:nvSpPr>
+          <p:cNvPr id="13" name="Rectangle 12"/>
+          <p:cNvSpPr/>
+          <p:nvPr/>
+        </p:nvSpPr>
+        <p:spPr>
+          <a:xfrm>
+            <a:off x="4187952" y="2377440"/>
+            <a:ext cx="3429000" cy="128016"/>
           </a:xfrm>
           <a:prstGeom prst="rect">
             <a:avLst/>
@@ -4764,125 +5611,20 @@
       </p:sp>
       <p:sp>
         <p:nvSpPr>
-          <p:cNvPr id="3" name="TextBox 2"/>
-          <p:cNvSpPr txBox="1"/>
-          <p:nvPr/>
-        </p:nvSpPr>
-        <p:spPr>
-          <a:xfrm>
-            <a:off x="457200" y="320040"/>
-            <a:ext cx="8229600" cy="411480"/>
-          </a:xfrm>
-          <a:prstGeom prst="rect">
-            <a:avLst/>
-          </a:prstGeom>
-          <a:noFill/>
-        </p:spPr>
-        <p:txBody>
-          <a:bodyPr wrap="square">
-            <a:spAutoFit/>
-          </a:bodyPr>
-          <a:lstStyle/>
-          <a:p>
-            <a:pPr algn="l"/>
-            <a:r>
-              <a:rPr sz="1200" b="1" i="0">
-                <a:solidFill>
-                  <a:srgbClr val="F5A623"/>
-                </a:solidFill>
-                <a:latin typeface="Calibri"/>
-              </a:rPr>
-              <a:t>ASÍ FUNCIONA</a:t>
-            </a:r>
-          </a:p>
-        </p:txBody>
-      </p:sp>
-      <p:sp>
-        <p:nvSpPr>
-          <p:cNvPr id="4" name="TextBox 3"/>
-          <p:cNvSpPr txBox="1"/>
-          <p:nvPr/>
-        </p:nvSpPr>
-        <p:spPr>
-          <a:xfrm>
-            <a:off x="457200" y="822960"/>
-            <a:ext cx="8229600" cy="777240"/>
-          </a:xfrm>
-          <a:prstGeom prst="rect">
-            <a:avLst/>
-          </a:prstGeom>
-          <a:noFill/>
-        </p:spPr>
-        <p:txBody>
-          <a:bodyPr wrap="square">
-            <a:spAutoFit/>
-          </a:bodyPr>
-          <a:lstStyle/>
-          <a:p>
-            <a:pPr algn="l"/>
-            <a:r>
-              <a:rPr sz="4200" b="1" i="0">
-                <a:solidFill>
-                  <a:srgbClr val="1C1C2E"/>
-                </a:solidFill>
-                <a:latin typeface="Calibri"/>
-              </a:rPr>
-              <a:t>El semáforo de tu coche</a:t>
-            </a:r>
-          </a:p>
-        </p:txBody>
-      </p:sp>
-      <p:sp>
-        <p:nvSpPr>
-          <p:cNvPr id="5" name="TextBox 4"/>
-          <p:cNvSpPr txBox="1"/>
-          <p:nvPr/>
-        </p:nvSpPr>
-        <p:spPr>
-          <a:xfrm>
-            <a:off x="457200" y="1691640"/>
-            <a:ext cx="8229600" cy="457200"/>
-          </a:xfrm>
-          <a:prstGeom prst="rect">
-            <a:avLst/>
-          </a:prstGeom>
-          <a:noFill/>
-        </p:spPr>
-        <p:txBody>
-          <a:bodyPr wrap="square">
-            <a:spAutoFit/>
-          </a:bodyPr>
-          <a:lstStyle/>
-          <a:p>
-            <a:pPr algn="l"/>
-            <a:r>
-              <a:rPr sz="1700" b="0" i="0">
-                <a:solidFill>
-                  <a:srgbClr val="4A5568"/>
-                </a:solidFill>
-                <a:latin typeface="Calibri"/>
-              </a:rPr>
-              <a:t>Un vistazo y sabes exactamente qué necesita atención.</a:t>
-            </a:r>
-          </a:p>
-        </p:txBody>
-      </p:sp>
-      <p:sp>
-        <p:nvSpPr>
-          <p:cNvPr id="6" name="Oval 5"/>
+          <p:cNvPr id="14" name="Oval 13"/>
           <p:cNvSpPr/>
           <p:nvPr/>
         </p:nvSpPr>
         <p:spPr>
           <a:xfrm>
-            <a:off x="1554480" y="2651760"/>
-            <a:ext cx="1371600" cy="1371600"/>
+            <a:off x="5353812" y="2743200"/>
+            <a:ext cx="1097280" cy="1097280"/>
           </a:xfrm>
           <a:prstGeom prst="ellipse">
             <a:avLst/>
           </a:prstGeom>
           <a:solidFill>
-            <a:srgbClr val="27AE60"/>
+            <a:srgbClr val="F5A623"/>
           </a:solidFill>
           <a:ln>
             <a:noFill/>
@@ -4912,14 +5654,85 @@
       </p:sp>
       <p:sp>
         <p:nvSpPr>
-          <p:cNvPr id="7" name="Rectangle 6"/>
+          <p:cNvPr id="15" name="TextBox 14"/>
+          <p:cNvSpPr txBox="1"/>
+          <p:nvPr/>
+        </p:nvSpPr>
+        <p:spPr>
+          <a:xfrm>
+            <a:off x="4352544" y="4005072"/>
+            <a:ext cx="3108960" cy="502920"/>
+          </a:xfrm>
+          <a:prstGeom prst="rect">
+            <a:avLst/>
+          </a:prstGeom>
+          <a:noFill/>
+        </p:spPr>
+        <p:txBody>
+          <a:bodyPr wrap="square">
+            <a:spAutoFit/>
+          </a:bodyPr>
+          <a:lstStyle/>
+          <a:p>
+            <a:pPr algn="l"/>
+            <a:r>
+              <a:rPr sz="2000" b="1" i="0">
+                <a:solidFill>
+                  <a:srgbClr val="0A1E35"/>
+                </a:solidFill>
+                <a:latin typeface="Calibri"/>
+              </a:rPr>
+              <a:t>Próximamente</a:t>
+            </a:r>
+          </a:p>
+        </p:txBody>
+      </p:sp>
+      <p:sp>
+        <p:nvSpPr>
+          <p:cNvPr id="16" name="TextBox 15"/>
+          <p:cNvSpPr txBox="1"/>
+          <p:nvPr/>
+        </p:nvSpPr>
+        <p:spPr>
+          <a:xfrm>
+            <a:off x="4352544" y="4553712"/>
+            <a:ext cx="3108960" cy="1005840"/>
+          </a:xfrm>
+          <a:prstGeom prst="rect">
+            <a:avLst/>
+          </a:prstGeom>
+          <a:noFill/>
+        </p:spPr>
+        <p:txBody>
+          <a:bodyPr wrap="square">
+            <a:spAutoFit/>
+          </a:bodyPr>
+          <a:lstStyle/>
+          <a:p>
+            <a:pPr algn="l"/>
+            <a:r>
+              <a:rPr sz="1400" b="0" i="0">
+                <a:solidFill>
+                  <a:srgbClr val="3D6080"/>
+                </a:solidFill>
+                <a:latin typeface="Calibri"/>
+              </a:rPr>
+              <a:t>Revisión cerca.
+Prepárate a tiempo.</a:t>
+            </a:r>
+          </a:p>
+        </p:txBody>
+      </p:sp>
+      <p:sp>
+        <p:nvSpPr>
+          <p:cNvPr id="17" name="Rectangle 16"/>
           <p:cNvSpPr/>
           <p:nvPr/>
         </p:nvSpPr>
         <p:spPr>
           <a:xfrm>
-            <a:off x="457200" y="2468880"/>
-            <a:ext cx="3566160" cy="3383280"/>
+            <a:off x="7964424" y="2377440"/>
+            <a:ext cx="3429000" cy="3520440"/>
           </a:xfrm>
           <a:prstGeom prst="rect">
             <a:avLst/>
@@ -4927,9 +5740,9 @@
           <a:solidFill>
             <a:srgbClr val="FFFFFF"/>
           </a:solidFill>
-          <a:ln w="25400">
+          <a:ln w="31750">
             <a:solidFill>
-              <a:srgbClr val="27AE60"/>
+              <a:srgbClr val="E8453C"/>
             </a:solidFill>
           </a:ln>
         </p:spPr>
@@ -4957,20 +5770,20 @@
       </p:sp>
       <p:sp>
         <p:nvSpPr>
-          <p:cNvPr id="8" name="Rectangle 7"/>
+          <p:cNvPr id="18" name="Rectangle 17"/>
           <p:cNvSpPr/>
           <p:nvPr/>
         </p:nvSpPr>
         <p:spPr>
           <a:xfrm>
-            <a:off x="457200" y="2468880"/>
-            <a:ext cx="3566160" cy="109728"/>
+            <a:off x="7964424" y="2377440"/>
+            <a:ext cx="3429000" cy="128016"/>
           </a:xfrm>
           <a:prstGeom prst="rect">
             <a:avLst/>
           </a:prstGeom>
           <a:solidFill>
-            <a:srgbClr val="27AE60"/>
+            <a:srgbClr val="E8453C"/>
           </a:solidFill>
           <a:ln>
             <a:noFill/>
@@ -5000,20 +5813,20 @@
       </p:sp>
       <p:sp>
         <p:nvSpPr>
-          <p:cNvPr id="9" name="Oval 8"/>
+          <p:cNvPr id="19" name="Oval 18"/>
           <p:cNvSpPr/>
           <p:nvPr/>
         </p:nvSpPr>
         <p:spPr>
           <a:xfrm>
-            <a:off x="1783080" y="2788920"/>
-            <a:ext cx="914400" cy="914400"/>
+            <a:off x="9130284" y="2743200"/>
+            <a:ext cx="1097280" cy="1097280"/>
           </a:xfrm>
           <a:prstGeom prst="ellipse">
             <a:avLst/>
           </a:prstGeom>
           <a:solidFill>
-            <a:srgbClr val="27AE60"/>
+            <a:srgbClr val="E8453C"/>
           </a:solidFill>
           <a:ln>
             <a:noFill/>
@@ -5043,14 +5856,14 @@
       </p:sp>
       <p:sp>
         <p:nvSpPr>
-          <p:cNvPr id="10" name="TextBox 9"/>
+          <p:cNvPr id="20" name="TextBox 19"/>
           <p:cNvSpPr txBox="1"/>
           <p:nvPr/>
         </p:nvSpPr>
         <p:spPr>
           <a:xfrm>
-            <a:off x="594360" y="3886200"/>
-            <a:ext cx="3291840" cy="502920"/>
+            <a:off x="8129016" y="4005072"/>
+            <a:ext cx="3108960" cy="502920"/>
           </a:xfrm>
           <a:prstGeom prst="rect">
             <a:avLst/>
@@ -5067,497 +5880,7 @@
             <a:r>
               <a:rPr sz="2000" b="1" i="0">
                 <a:solidFill>
-                  <a:srgbClr val="1C1C2E"/>
-                </a:solidFill>
-                <a:latin typeface="Calibri"/>
-              </a:rPr>
-              <a:t>Todo en orden</a:t>
-            </a:r>
-          </a:p>
-        </p:txBody>
-      </p:sp>
-      <p:sp>
-        <p:nvSpPr>
-          <p:cNvPr id="11" name="TextBox 10"/>
-          <p:cNvSpPr txBox="1"/>
-          <p:nvPr/>
-        </p:nvSpPr>
-        <p:spPr>
-          <a:xfrm>
-            <a:off x="594360" y="4434840"/>
-            <a:ext cx="3291840" cy="1005840"/>
-          </a:xfrm>
-          <a:prstGeom prst="rect">
-            <a:avLst/>
-          </a:prstGeom>
-          <a:noFill/>
-        </p:spPr>
-        <p:txBody>
-          <a:bodyPr wrap="square">
-            <a:spAutoFit/>
-          </a:bodyPr>
-          <a:lstStyle/>
-          <a:p>
-            <a:pPr algn="l"/>
-            <a:r>
-              <a:rPr sz="1400" b="0" i="0">
-                <a:solidFill>
-                  <a:srgbClr val="4A5568"/>
-                </a:solidFill>
-                <a:latin typeface="Calibri"/>
-              </a:rPr>
-              <a:t>Revisiones al día.
-Sin preocupaciones.</a:t>
-            </a:r>
-          </a:p>
-        </p:txBody>
-      </p:sp>
-      <p:sp>
-        <p:nvSpPr>
-          <p:cNvPr id="12" name="Oval 11"/>
-          <p:cNvSpPr/>
-          <p:nvPr/>
-        </p:nvSpPr>
-        <p:spPr>
-          <a:xfrm>
-            <a:off x="5413248" y="2651760"/>
-            <a:ext cx="1371600" cy="1371600"/>
-          </a:xfrm>
-          <a:prstGeom prst="ellipse">
-            <a:avLst/>
-          </a:prstGeom>
-          <a:solidFill>
-            <a:srgbClr val="F39C12"/>
-          </a:solidFill>
-          <a:ln>
-            <a:noFill/>
-          </a:ln>
-        </p:spPr>
-        <p:style>
-          <a:lnRef idx="1">
-            <a:schemeClr val="accent1"/>
-          </a:lnRef>
-          <a:fillRef idx="3">
-            <a:schemeClr val="accent1"/>
-          </a:fillRef>
-          <a:effectRef idx="2">
-            <a:schemeClr val="accent1"/>
-          </a:effectRef>
-          <a:fontRef idx="minor">
-            <a:schemeClr val="lt1"/>
-          </a:fontRef>
-        </p:style>
-        <p:txBody>
-          <a:bodyPr rtlCol="0" anchor="ctr"/>
-          <a:lstStyle/>
-          <a:p>
-            <a:pPr algn="ctr"/>
-          </a:p>
-        </p:txBody>
-      </p:sp>
-      <p:sp>
-        <p:nvSpPr>
-          <p:cNvPr id="13" name="Rectangle 12"/>
-          <p:cNvSpPr/>
-          <p:nvPr/>
-        </p:nvSpPr>
-        <p:spPr>
-          <a:xfrm>
-            <a:off x="4315968" y="2468880"/>
-            <a:ext cx="3566160" cy="3383280"/>
-          </a:xfrm>
-          <a:prstGeom prst="rect">
-            <a:avLst/>
-          </a:prstGeom>
-          <a:solidFill>
-            <a:srgbClr val="FFFFFF"/>
-          </a:solidFill>
-          <a:ln w="25400">
-            <a:solidFill>
-              <a:srgbClr val="F39C12"/>
-            </a:solidFill>
-          </a:ln>
-        </p:spPr>
-        <p:style>
-          <a:lnRef idx="1">
-            <a:schemeClr val="accent1"/>
-          </a:lnRef>
-          <a:fillRef idx="3">
-            <a:schemeClr val="accent1"/>
-          </a:fillRef>
-          <a:effectRef idx="2">
-            <a:schemeClr val="accent1"/>
-          </a:effectRef>
-          <a:fontRef idx="minor">
-            <a:schemeClr val="lt1"/>
-          </a:fontRef>
-        </p:style>
-        <p:txBody>
-          <a:bodyPr rtlCol="0" anchor="ctr"/>
-          <a:lstStyle/>
-          <a:p>
-            <a:pPr algn="ctr"/>
-          </a:p>
-        </p:txBody>
-      </p:sp>
-      <p:sp>
-        <p:nvSpPr>
-          <p:cNvPr id="14" name="Rectangle 13"/>
-          <p:cNvSpPr/>
-          <p:nvPr/>
-        </p:nvSpPr>
-        <p:spPr>
-          <a:xfrm>
-            <a:off x="4315968" y="2468880"/>
-            <a:ext cx="3566160" cy="109728"/>
-          </a:xfrm>
-          <a:prstGeom prst="rect">
-            <a:avLst/>
-          </a:prstGeom>
-          <a:solidFill>
-            <a:srgbClr val="F39C12"/>
-          </a:solidFill>
-          <a:ln>
-            <a:noFill/>
-          </a:ln>
-        </p:spPr>
-        <p:style>
-          <a:lnRef idx="1">
-            <a:schemeClr val="accent1"/>
-          </a:lnRef>
-          <a:fillRef idx="3">
-            <a:schemeClr val="accent1"/>
-          </a:fillRef>
-          <a:effectRef idx="2">
-            <a:schemeClr val="accent1"/>
-          </a:effectRef>
-          <a:fontRef idx="minor">
-            <a:schemeClr val="lt1"/>
-          </a:fontRef>
-        </p:style>
-        <p:txBody>
-          <a:bodyPr rtlCol="0" anchor="ctr"/>
-          <a:lstStyle/>
-          <a:p>
-            <a:pPr algn="ctr"/>
-          </a:p>
-        </p:txBody>
-      </p:sp>
-      <p:sp>
-        <p:nvSpPr>
-          <p:cNvPr id="15" name="Oval 14"/>
-          <p:cNvSpPr/>
-          <p:nvPr/>
-        </p:nvSpPr>
-        <p:spPr>
-          <a:xfrm>
-            <a:off x="5641848" y="2788920"/>
-            <a:ext cx="914400" cy="914400"/>
-          </a:xfrm>
-          <a:prstGeom prst="ellipse">
-            <a:avLst/>
-          </a:prstGeom>
-          <a:solidFill>
-            <a:srgbClr val="F39C12"/>
-          </a:solidFill>
-          <a:ln>
-            <a:noFill/>
-          </a:ln>
-        </p:spPr>
-        <p:style>
-          <a:lnRef idx="1">
-            <a:schemeClr val="accent1"/>
-          </a:lnRef>
-          <a:fillRef idx="3">
-            <a:schemeClr val="accent1"/>
-          </a:fillRef>
-          <a:effectRef idx="2">
-            <a:schemeClr val="accent1"/>
-          </a:effectRef>
-          <a:fontRef idx="minor">
-            <a:schemeClr val="lt1"/>
-          </a:fontRef>
-        </p:style>
-        <p:txBody>
-          <a:bodyPr rtlCol="0" anchor="ctr"/>
-          <a:lstStyle/>
-          <a:p>
-            <a:pPr algn="ctr"/>
-          </a:p>
-        </p:txBody>
-      </p:sp>
-      <p:sp>
-        <p:nvSpPr>
-          <p:cNvPr id="16" name="TextBox 15"/>
-          <p:cNvSpPr txBox="1"/>
-          <p:nvPr/>
-        </p:nvSpPr>
-        <p:spPr>
-          <a:xfrm>
-            <a:off x="4453128" y="3886200"/>
-            <a:ext cx="3291840" cy="502920"/>
-          </a:xfrm>
-          <a:prstGeom prst="rect">
-            <a:avLst/>
-          </a:prstGeom>
-          <a:noFill/>
-        </p:spPr>
-        <p:txBody>
-          <a:bodyPr wrap="square">
-            <a:spAutoFit/>
-          </a:bodyPr>
-          <a:lstStyle/>
-          <a:p>
-            <a:pPr algn="l"/>
-            <a:r>
-              <a:rPr sz="2000" b="1" i="0">
-                <a:solidFill>
-                  <a:srgbClr val="1C1C2E"/>
-                </a:solidFill>
-                <a:latin typeface="Calibri"/>
-              </a:rPr>
-              <a:t>Próximamente</a:t>
-            </a:r>
-          </a:p>
-        </p:txBody>
-      </p:sp>
-      <p:sp>
-        <p:nvSpPr>
-          <p:cNvPr id="17" name="TextBox 16"/>
-          <p:cNvSpPr txBox="1"/>
-          <p:nvPr/>
-        </p:nvSpPr>
-        <p:spPr>
-          <a:xfrm>
-            <a:off x="4453128" y="4434840"/>
-            <a:ext cx="3291840" cy="1005840"/>
-          </a:xfrm>
-          <a:prstGeom prst="rect">
-            <a:avLst/>
-          </a:prstGeom>
-          <a:noFill/>
-        </p:spPr>
-        <p:txBody>
-          <a:bodyPr wrap="square">
-            <a:spAutoFit/>
-          </a:bodyPr>
-          <a:lstStyle/>
-          <a:p>
-            <a:pPr algn="l"/>
-            <a:r>
-              <a:rPr sz="1400" b="0" i="0">
-                <a:solidFill>
-                  <a:srgbClr val="4A5568"/>
-                </a:solidFill>
-                <a:latin typeface="Calibri"/>
-              </a:rPr>
-              <a:t>Revisión cerca.
-Prepárate a tiempo.</a:t>
-            </a:r>
-          </a:p>
-        </p:txBody>
-      </p:sp>
-      <p:sp>
-        <p:nvSpPr>
-          <p:cNvPr id="18" name="Oval 17"/>
-          <p:cNvSpPr/>
-          <p:nvPr/>
-        </p:nvSpPr>
-        <p:spPr>
-          <a:xfrm>
-            <a:off x="9272015" y="2651760"/>
-            <a:ext cx="1371600" cy="1371600"/>
-          </a:xfrm>
-          <a:prstGeom prst="ellipse">
-            <a:avLst/>
-          </a:prstGeom>
-          <a:solidFill>
-            <a:srgbClr val="E74C3C"/>
-          </a:solidFill>
-          <a:ln>
-            <a:noFill/>
-          </a:ln>
-        </p:spPr>
-        <p:style>
-          <a:lnRef idx="1">
-            <a:schemeClr val="accent1"/>
-          </a:lnRef>
-          <a:fillRef idx="3">
-            <a:schemeClr val="accent1"/>
-          </a:fillRef>
-          <a:effectRef idx="2">
-            <a:schemeClr val="accent1"/>
-          </a:effectRef>
-          <a:fontRef idx="minor">
-            <a:schemeClr val="lt1"/>
-          </a:fontRef>
-        </p:style>
-        <p:txBody>
-          <a:bodyPr rtlCol="0" anchor="ctr"/>
-          <a:lstStyle/>
-          <a:p>
-            <a:pPr algn="ctr"/>
-          </a:p>
-        </p:txBody>
-      </p:sp>
-      <p:sp>
-        <p:nvSpPr>
-          <p:cNvPr id="19" name="Rectangle 18"/>
-          <p:cNvSpPr/>
-          <p:nvPr/>
-        </p:nvSpPr>
-        <p:spPr>
-          <a:xfrm>
-            <a:off x="8174736" y="2468880"/>
-            <a:ext cx="3566160" cy="3383280"/>
-          </a:xfrm>
-          <a:prstGeom prst="rect">
-            <a:avLst/>
-          </a:prstGeom>
-          <a:solidFill>
-            <a:srgbClr val="FFFFFF"/>
-          </a:solidFill>
-          <a:ln w="25400">
-            <a:solidFill>
-              <a:srgbClr val="E74C3C"/>
-            </a:solidFill>
-          </a:ln>
-        </p:spPr>
-        <p:style>
-          <a:lnRef idx="1">
-            <a:schemeClr val="accent1"/>
-          </a:lnRef>
-          <a:fillRef idx="3">
-            <a:schemeClr val="accent1"/>
-          </a:fillRef>
-          <a:effectRef idx="2">
-            <a:schemeClr val="accent1"/>
-          </a:effectRef>
-          <a:fontRef idx="minor">
-            <a:schemeClr val="lt1"/>
-          </a:fontRef>
-        </p:style>
-        <p:txBody>
-          <a:bodyPr rtlCol="0" anchor="ctr"/>
-          <a:lstStyle/>
-          <a:p>
-            <a:pPr algn="ctr"/>
-          </a:p>
-        </p:txBody>
-      </p:sp>
-      <p:sp>
-        <p:nvSpPr>
-          <p:cNvPr id="20" name="Rectangle 19"/>
-          <p:cNvSpPr/>
-          <p:nvPr/>
-        </p:nvSpPr>
-        <p:spPr>
-          <a:xfrm>
-            <a:off x="8174736" y="2468880"/>
-            <a:ext cx="3566160" cy="109728"/>
-          </a:xfrm>
-          <a:prstGeom prst="rect">
-            <a:avLst/>
-          </a:prstGeom>
-          <a:solidFill>
-            <a:srgbClr val="E74C3C"/>
-          </a:solidFill>
-          <a:ln>
-            <a:noFill/>
-          </a:ln>
-        </p:spPr>
-        <p:style>
-          <a:lnRef idx="1">
-            <a:schemeClr val="accent1"/>
-          </a:lnRef>
-          <a:fillRef idx="3">
-            <a:schemeClr val="accent1"/>
-          </a:fillRef>
-          <a:effectRef idx="2">
-            <a:schemeClr val="accent1"/>
-          </a:effectRef>
-          <a:fontRef idx="minor">
-            <a:schemeClr val="lt1"/>
-          </a:fontRef>
-        </p:style>
-        <p:txBody>
-          <a:bodyPr rtlCol="0" anchor="ctr"/>
-          <a:lstStyle/>
-          <a:p>
-            <a:pPr algn="ctr"/>
-          </a:p>
-        </p:txBody>
-      </p:sp>
-      <p:sp>
-        <p:nvSpPr>
-          <p:cNvPr id="21" name="Oval 20"/>
-          <p:cNvSpPr/>
-          <p:nvPr/>
-        </p:nvSpPr>
-        <p:spPr>
-          <a:xfrm>
-            <a:off x="9500615" y="2788920"/>
-            <a:ext cx="914400" cy="914400"/>
-          </a:xfrm>
-          <a:prstGeom prst="ellipse">
-            <a:avLst/>
-          </a:prstGeom>
-          <a:solidFill>
-            <a:srgbClr val="E74C3C"/>
-          </a:solidFill>
-          <a:ln>
-            <a:noFill/>
-          </a:ln>
-        </p:spPr>
-        <p:style>
-          <a:lnRef idx="1">
-            <a:schemeClr val="accent1"/>
-          </a:lnRef>
-          <a:fillRef idx="3">
-            <a:schemeClr val="accent1"/>
-          </a:fillRef>
-          <a:effectRef idx="2">
-            <a:schemeClr val="accent1"/>
-          </a:effectRef>
-          <a:fontRef idx="minor">
-            <a:schemeClr val="lt1"/>
-          </a:fontRef>
-        </p:style>
-        <p:txBody>
-          <a:bodyPr rtlCol="0" anchor="ctr"/>
-          <a:lstStyle/>
-          <a:p>
-            <a:pPr algn="ctr"/>
-          </a:p>
-        </p:txBody>
-      </p:sp>
-      <p:sp>
-        <p:nvSpPr>
-          <p:cNvPr id="22" name="TextBox 21"/>
-          <p:cNvSpPr txBox="1"/>
-          <p:nvPr/>
-        </p:nvSpPr>
-        <p:spPr>
-          <a:xfrm>
-            <a:off x="8311896" y="3886200"/>
-            <a:ext cx="3291840" cy="502920"/>
-          </a:xfrm>
-          <a:prstGeom prst="rect">
-            <a:avLst/>
-          </a:prstGeom>
-          <a:noFill/>
-        </p:spPr>
-        <p:txBody>
-          <a:bodyPr wrap="square">
-            <a:spAutoFit/>
-          </a:bodyPr>
-          <a:lstStyle/>
-          <a:p>
-            <a:pPr algn="l"/>
-            <a:r>
-              <a:rPr sz="2000" b="1" i="0">
-                <a:solidFill>
-                  <a:srgbClr val="1C1C2E"/>
+                  <a:srgbClr val="0A1E35"/>
                 </a:solidFill>
                 <a:latin typeface="Calibri"/>
               </a:rPr>
@@ -5568,14 +5891,14 @@
       </p:sp>
       <p:sp>
         <p:nvSpPr>
-          <p:cNvPr id="23" name="TextBox 22"/>
+          <p:cNvPr id="21" name="TextBox 20"/>
           <p:cNvSpPr txBox="1"/>
           <p:nvPr/>
         </p:nvSpPr>
         <p:spPr>
           <a:xfrm>
-            <a:off x="8311896" y="4434840"/>
-            <a:ext cx="3291840" cy="1005840"/>
+            <a:off x="8129016" y="4553712"/>
+            <a:ext cx="3108960" cy="1005840"/>
           </a:xfrm>
           <a:prstGeom prst="rect">
             <a:avLst/>
@@ -5592,7 +5915,7 @@
             <a:r>
               <a:rPr sz="1400" b="0" i="0">
                 <a:solidFill>
-                  <a:srgbClr val="4A5568"/>
+                  <a:srgbClr val="3D6080"/>
                 </a:solidFill>
                 <a:latin typeface="Calibri"/>
               </a:rPr>
@@ -5616,7 +5939,7 @@
     <p:bg>
       <p:bgPr>
         <a:solidFill>
-          <a:srgbClr val="12122A"/>
+          <a:srgbClr val="016CB0"/>
         </a:solidFill>
         <a:effectLst/>
       </p:bgPr>
@@ -5636,14 +5959,14 @@
         </p:nvSpPr>
         <p:spPr>
           <a:xfrm>
-            <a:off x="0" y="0"/>
-            <a:ext cx="164592" cy="6858000"/>
+            <a:off x="8961120" y="0"/>
+            <a:ext cx="3227832" cy="6858000"/>
           </a:xfrm>
           <a:prstGeom prst="rect">
             <a:avLst/>
           </a:prstGeom>
           <a:solidFill>
-            <a:srgbClr val="F5A623"/>
+            <a:srgbClr val="013E68"/>
           </a:solidFill>
           <a:ln>
             <a:noFill/>
@@ -5687,8 +6010,8 @@
         </p:blipFill>
         <p:spPr>
           <a:xfrm>
-            <a:off x="9601200" y="457200"/>
-            <a:ext cx="2011680" cy="2011680"/>
+            <a:off x="9189720" y="1645920"/>
+            <a:ext cx="2743200" cy="2743200"/>
           </a:xfrm>
           <a:prstGeom prst="rect">
             <a:avLst/>
@@ -5697,14 +6020,57 @@
       </p:pic>
       <p:sp>
         <p:nvSpPr>
-          <p:cNvPr id="4" name="TextBox 3"/>
+          <p:cNvPr id="4" name="Rectangle 3"/>
+          <p:cNvSpPr/>
+          <p:nvPr/>
+        </p:nvSpPr>
+        <p:spPr>
+          <a:xfrm>
+            <a:off x="8942832" y="0"/>
+            <a:ext cx="36576" cy="6858000"/>
+          </a:xfrm>
+          <a:prstGeom prst="rect">
+            <a:avLst/>
+          </a:prstGeom>
+          <a:solidFill>
+            <a:srgbClr val="FFFFFF"/>
+          </a:solidFill>
+          <a:ln>
+            <a:noFill/>
+          </a:ln>
+        </p:spPr>
+        <p:style>
+          <a:lnRef idx="1">
+            <a:schemeClr val="accent1"/>
+          </a:lnRef>
+          <a:fillRef idx="3">
+            <a:schemeClr val="accent1"/>
+          </a:fillRef>
+          <a:effectRef idx="2">
+            <a:schemeClr val="accent1"/>
+          </a:effectRef>
+          <a:fontRef idx="minor">
+            <a:schemeClr val="lt1"/>
+          </a:fontRef>
+        </p:style>
+        <p:txBody>
+          <a:bodyPr rtlCol="0" anchor="ctr"/>
+          <a:lstStyle/>
+          <a:p>
+            <a:pPr algn="ctr"/>
+          </a:p>
+        </p:txBody>
+      </p:sp>
+      <p:sp>
+        <p:nvSpPr>
+          <p:cNvPr id="5" name="TextBox 4"/>
           <p:cNvSpPr txBox="1"/>
           <p:nvPr/>
         </p:nvSpPr>
         <p:spPr>
           <a:xfrm>
-            <a:off x="457200" y="822960"/>
-            <a:ext cx="8229600" cy="457200"/>
+            <a:off x="411480" y="822960"/>
+            <a:ext cx="8229600" cy="411480"/>
           </a:xfrm>
           <a:prstGeom prst="rect">
             <a:avLst/>
@@ -5719,9 +6085,9 @@
           <a:p>
             <a:pPr algn="l"/>
             <a:r>
-              <a:rPr sz="1300" b="1" i="0">
+              <a:rPr sz="1100" b="1" i="0">
                 <a:solidFill>
-                  <a:srgbClr val="F5A623"/>
+                  <a:srgbClr val="A8D8F0"/>
                 </a:solidFill>
                 <a:latin typeface="Calibri"/>
               </a:rPr>
@@ -5732,14 +6098,14 @@
       </p:sp>
       <p:sp>
         <p:nvSpPr>
-          <p:cNvPr id="5" name="TextBox 4"/>
+          <p:cNvPr id="6" name="TextBox 5"/>
           <p:cNvSpPr txBox="1"/>
           <p:nvPr/>
         </p:nvSpPr>
         <p:spPr>
           <a:xfrm>
-            <a:off x="457200" y="1371600"/>
-            <a:ext cx="8229600" cy="1645920"/>
+            <a:off x="411480" y="1417320"/>
+            <a:ext cx="8229600" cy="1737360"/>
           </a:xfrm>
           <a:prstGeom prst="rect">
             <a:avLst/>
@@ -5768,14 +6134,14 @@
       </p:sp>
       <p:sp>
         <p:nvSpPr>
-          <p:cNvPr id="6" name="TextBox 5"/>
+          <p:cNvPr id="7" name="TextBox 6"/>
           <p:cNvSpPr txBox="1"/>
           <p:nvPr/>
         </p:nvSpPr>
         <p:spPr>
           <a:xfrm>
-            <a:off x="457200" y="3154680"/>
-            <a:ext cx="8229600" cy="457200"/>
+            <a:off x="411480" y="3246120"/>
+            <a:ext cx="8321040" cy="457200"/>
           </a:xfrm>
           <a:prstGeom prst="rect">
             <a:avLst/>
@@ -5790,33 +6156,33 @@
           <a:p>
             <a:pPr algn="l"/>
             <a:r>
-              <a:rPr sz="1500" b="0" i="0">
+              <a:rPr sz="1400" b="0" i="0">
                 <a:solidFill>
-                  <a:srgbClr val="8888AA"/>
+                  <a:srgbClr val="A8CCE8"/>
                 </a:solidFill>
                 <a:latin typeface="Calibri"/>
               </a:rPr>
-              <a:t>Sin instalar nada · Web responsive · Funciona en cualquier móvil</a:t>
-            </a:r>
-          </a:p>
-        </p:txBody>
-      </p:sp>
-      <p:sp>
-        <p:nvSpPr>
-          <p:cNvPr id="7" name="Rectangle 6"/>
+              <a:t>Sin instalar nada  ·  Web responsive  ·  Funciona en cualquier móvil</a:t>
+            </a:r>
+          </a:p>
+        </p:txBody>
+      </p:sp>
+      <p:sp>
+        <p:nvSpPr>
+          <p:cNvPr id="8" name="Rectangle 7"/>
           <p:cNvSpPr/>
           <p:nvPr/>
         </p:nvSpPr>
         <p:spPr>
           <a:xfrm>
-            <a:off x="457200" y="3749039"/>
-            <a:ext cx="5029200" cy="868680"/>
+            <a:off x="411480" y="3886200"/>
+            <a:ext cx="5943600" cy="868680"/>
           </a:xfrm>
           <a:prstGeom prst="rect">
             <a:avLst/>
           </a:prstGeom>
           <a:solidFill>
-            <a:srgbClr val="F5A623"/>
+            <a:srgbClr val="013E68"/>
           </a:solidFill>
           <a:ln>
             <a:noFill/>
@@ -5846,14 +6212,14 @@
       </p:sp>
       <p:sp>
         <p:nvSpPr>
-          <p:cNvPr id="8" name="TextBox 7"/>
+          <p:cNvPr id="9" name="TextBox 8"/>
           <p:cNvSpPr txBox="1"/>
           <p:nvPr/>
         </p:nvSpPr>
         <p:spPr>
           <a:xfrm>
-            <a:off x="457200" y="3749039"/>
-            <a:ext cx="5029200" cy="868680"/>
+            <a:off x="411480" y="3886200"/>
+            <a:ext cx="5943600" cy="868680"/>
           </a:xfrm>
           <a:prstGeom prst="rect">
             <a:avLst/>
@@ -5869,11 +6235,11 @@
             <a:pPr algn="ctr"/>
             <a:r>
               <a:rPr sz="2000" b="1">
+                <a:solidFill>
+                  <a:srgbClr val="FFFFFF"/>
+                </a:solidFill>
                 <a:latin typeface="Calibri"/>
                 <a:hlinkClick r:id="rId3"/>
-                <a:solidFill>
-                  <a:srgbClr val="12122A"/>
-                </a:solidFill>
               </a:rPr>
               <a:t>car-tracker-ten.vercel.app/landing</a:t>
             </a:r>
@@ -5882,14 +6248,14 @@
       </p:sp>
       <p:sp>
         <p:nvSpPr>
-          <p:cNvPr id="9" name="TextBox 8"/>
+          <p:cNvPr id="10" name="TextBox 9"/>
           <p:cNvSpPr txBox="1"/>
           <p:nvPr/>
         </p:nvSpPr>
         <p:spPr>
           <a:xfrm>
-            <a:off x="457200" y="4754880"/>
-            <a:ext cx="5029200" cy="365760"/>
+            <a:off x="411480" y="4892040"/>
+            <a:ext cx="5943600" cy="365760"/>
           </a:xfrm>
           <a:prstGeom prst="rect">
             <a:avLst/>
@@ -5906,7 +6272,7 @@
             <a:r>
               <a:rPr sz="1200" b="0" i="1">
                 <a:solidFill>
-                  <a:srgbClr val="AAAACC"/>
+                  <a:srgbClr val="7AB8D8"/>
                 </a:solidFill>
                 <a:latin typeface="Calibri"/>
               </a:rPr>
@@ -5917,20 +6283,20 @@
       </p:sp>
       <p:sp>
         <p:nvSpPr>
-          <p:cNvPr id="10" name="Rectangle 9"/>
+          <p:cNvPr id="11" name="Rectangle 10"/>
           <p:cNvSpPr/>
           <p:nvPr/>
         </p:nvSpPr>
         <p:spPr>
           <a:xfrm>
             <a:off x="0" y="6217920"/>
-            <a:ext cx="12188952" cy="640080"/>
+            <a:ext cx="8961120" cy="640080"/>
           </a:xfrm>
           <a:prstGeom prst="rect">
             <a:avLst/>
           </a:prstGeom>
           <a:solidFill>
-            <a:srgbClr val="0D0D22"/>
+            <a:srgbClr val="014F82"/>
           </a:solidFill>
           <a:ln>
             <a:noFill/>
@@ -5960,14 +6326,14 @@
       </p:sp>
       <p:sp>
         <p:nvSpPr>
-          <p:cNvPr id="11" name="TextBox 10"/>
+          <p:cNvPr id="12" name="TextBox 11"/>
           <p:cNvSpPr txBox="1"/>
           <p:nvPr/>
         </p:nvSpPr>
         <p:spPr>
           <a:xfrm>
-            <a:off x="457200" y="6281928"/>
-            <a:ext cx="10972800" cy="457200"/>
+            <a:off x="411480" y="6281928"/>
+            <a:ext cx="8229600" cy="457200"/>
           </a:xfrm>
           <a:prstGeom prst="rect">
             <a:avLst/>
@@ -5984,7 +6350,7 @@
             <a:r>
               <a:rPr sz="1100" b="0" i="0">
                 <a:solidFill>
-                  <a:srgbClr val="4444AA"/>
+                  <a:srgbClr val="6AAED0"/>
                 </a:solidFill>
                 <a:latin typeface="Calibri"/>
               </a:rPr>

</xml_diff>